<commit_message>
Update presentation for 16-condition results
</commit_message>
<xml_diff>
--- a/homeostasis_security_presentation(2).pptx
+++ b/homeostasis_security_presentation(2).pptx
@@ -3081,7 +3081,7 @@
 </file>
 
 <file path=ppt/slides/slide1.xml><?xml version="1.0" encoding="utf-8"?>
-<p:sld xmlns:a="http://schemas.openxmlformats.org/drawingml/2006/main" xmlns:p="http://schemas.openxmlformats.org/presentationml/2006/main" xmlns:r="http://schemas.openxmlformats.org/officeDocument/2006/relationships">
+<p:sld xmlns:a="http://schemas.openxmlformats.org/drawingml/2006/main" xmlns:p="http://schemas.openxmlformats.org/presentationml/2006/main">
   <p:cSld>
     <p:bg>
       <p:bgPr>
@@ -3128,7 +3128,7 @@
               </a:defRPr>
             </a:pPr>
             <a:r>
-              <a:t>CONCEPT &amp; VISION</a:t>
+              <a:t>CONCEPT &amp; PURPOSE</a:t>
             </a:r>
           </a:p>
         </p:txBody>
@@ -3163,7 +3163,7 @@
               </a:defRPr>
             </a:pPr>
             <a:r>
-              <a:t>世界を「ひとつの生命システム」として見る</a:t>
+              <a:t>HOMEOSTASIS SECURITY</a:t>
             </a:r>
           </a:p>
         </p:txBody>
@@ -3198,72 +3198,51 @@
               </a:defRPr>
             </a:pPr>
             <a:r>
-              <a:t>人間の身体には、外部環境が変化しても、</a:t>
+              <a:t>国家の安全保障反応を、生命体の「免疫反応」として捉える。</a:t>
             </a:r>
             <a:br/>
             <a:r>
-              <a:t>その変化を感知し、調整しながら安定状態へ戻ろうとする</a:t>
+              <a:t/>
             </a:r>
             <a:br/>
             <a:r>
-              <a:t>「恒常性（Homeostasis）」があります。</a:t>
+              <a:t>脅威に対する反応が強すぎれば、相手国の警戒を高め、</a:t>
             </a:r>
             <a:br/>
+            <a:r>
+              <a:t>さらなる対抗措置を招く。弱すぎれば、必要な防衛を欠く。</a:t>
+            </a:r>
             <a:br/>
             <a:r>
-              <a:t>そこで本作品では、この考え方を</a:t>
+              <a:t/>
             </a:r>
             <a:br/>
             <a:r>
-              <a:t>国家と国家の関係、そして世界全体の安全保障へ応用しました。</a:t>
+              <a:t>本作品は、独立した国家AI Agentに結末を指示しない。</a:t>
             </a:r>
             <a:br/>
+            <a:r>
+              <a:t>国家利益と認識した脅威をもとに、それぞれが行動を判断する。</a:t>
+            </a:r>
             <a:br/>
             <a:r>
-              <a:t>国家による警戒・防衛・対抗措置は、</a:t>
+              <a:t/>
             </a:r>
             <a:br/>
             <a:r>
-              <a:t>生命体でいえば外部の脅威から身体を守る「免疫反応」に似ています。</a:t>
+              <a:t>Agent同士の相互作用を観測し、</a:t>
             </a:r>
             <a:br/>
+            <a:r>
+              <a:t>対立が起きても破壊へ向かわず、平衡を回復できる条件を探る。</a:t>
+            </a:r>
             <a:br/>
             <a:r>
-              <a:t>しかし、免疫反応が強すぎれば自らの身体を傷つけるように、</a:t>
+              <a:t/>
             </a:r>
             <a:br/>
             <a:r>
-              <a:t>国家の過剰な警戒や防衛も、相手国には新たな脅威として観測され、</a:t>
-            </a:r>
-            <a:br/>
-            <a:r>
-              <a:t>さらなる警戒や対抗措置を生み出します。</a:t>
-            </a:r>
-            <a:br/>
-            <a:br/>
-            <a:r>
-              <a:t>一国だけが安全であればいいのではない。</a:t>
-            </a:r>
-            <a:br/>
-            <a:r>
-              <a:t>国家と国家の関係そのものが、</a:t>
-            </a:r>
-            <a:br/>
-            <a:r>
-              <a:t>変化や対立を受けても破壊されず、</a:t>
-            </a:r>
-            <a:br/>
-            <a:r>
-              <a:t>再び安定へ戻ることができるのか。</a:t>
-            </a:r>
-            <a:br/>
-            <a:br/>
-            <a:r>
-              <a:t>本作品は、世界の安全保障を</a:t>
-            </a:r>
-            <a:br/>
-            <a:r>
-              <a:t>「勝敗」ではなく「恒常性」から捉え直す試みです。</a:t>
+              <a:t>安全保障を「勝敗」ではなく「恒常性」から捉え直す試み。</a:t>
             </a:r>
           </a:p>
         </p:txBody>
@@ -3277,7 +3256,7 @@
 </file>
 
 <file path=ppt/slides/slide2.xml><?xml version="1.0" encoding="utf-8"?>
-<p:sld xmlns:a="http://schemas.openxmlformats.org/drawingml/2006/main" xmlns:p="http://schemas.openxmlformats.org/presentationml/2006/main" xmlns:r="http://schemas.openxmlformats.org/officeDocument/2006/relationships">
+<p:sld xmlns:a="http://schemas.openxmlformats.org/drawingml/2006/main" xmlns:p="http://schemas.openxmlformats.org/presentationml/2006/main">
   <p:cSld>
     <p:bg>
       <p:bgPr>
@@ -3324,7 +3303,7 @@
               </a:defRPr>
             </a:pPr>
             <a:r>
-              <a:t>RESEARCH QUESTION</a:t>
+              <a:t>EXPERIMENT DESIGN</a:t>
             </a:r>
           </a:p>
         </p:txBody>
@@ -3359,7 +3338,7 @@
               </a:defRPr>
             </a:pPr>
             <a:r>
-              <a:t>結末を決めない。AI Agentに判断させる。</a:t>
+              <a:t>A〜P 16条件・36 run比較</a:t>
             </a:r>
           </a:p>
         </p:txBody>
@@ -3394,88 +3373,55 @@
               </a:defRPr>
             </a:pPr>
             <a:r>
-              <a:t>本作品では、AIに</a:t>
+              <a:t>4つの国家タイプ組合せ × 4つの制度設定 = 16条件</a:t>
             </a:r>
             <a:br/>
             <a:r>
-              <a:t>「平和を選べ」「戦争を避けろ」といった</a:t>
+              <a:t/>
             </a:r>
             <a:br/>
             <a:r>
-              <a:t>望ましい結末を命令していません。</a:t>
+              <a:t>国家タイプ        法ON / HL ON   法ON / HL OFF   法OFF / HL ON   法OFF / HL OFF</a:t>
             </a:r>
             <a:br/>
             <a:r>
-              <a:t>設定するのは、「条件と環境」だけです。</a:t>
+              <a:t>慎重 × 慎重             A                    D                      C                       H</a:t>
             </a:r>
             <a:br/>
+            <a:r>
+              <a:t>強硬 × 強硬             B                    G                      F                       E</a:t>
+            </a:r>
             <a:br/>
             <a:r>
-              <a:t>国家利益、リーダーの性格、過去の記憶、認識した脅威。</a:t>
+              <a:t>強硬 × 慎重             I                     J                       K                       L</a:t>
             </a:r>
             <a:br/>
             <a:r>
-              <a:t>そして、国際法・Hotline・外交といった制度。</a:t>
+              <a:t>慎重 × 強硬             M                   N                      O                       P</a:t>
             </a:r>
             <a:br/>
             <a:r>
-              <a:t>その世界の中で、独立した国家AI Agentが状況を認識し、</a:t>
+              <a:t/>
             </a:r>
             <a:br/>
             <a:r>
-              <a:t>懸念を持ち、自ら次の行動を判断します。</a:t>
+              <a:t>A=5 run、D=3 run、その他14条件=各2 run　合計36 run</a:t>
             </a:r>
             <a:br/>
+            <a:r>
+              <a:t>各runは8 TURN</a:t>
+            </a:r>
             <a:br/>
             <a:r>
-              <a:t>結末を脚本化せず、</a:t>
+              <a:t/>
             </a:r>
             <a:br/>
             <a:r>
-              <a:t>AI Agent同士の相互作用から</a:t>
+              <a:t>独立したA国・B国Agentが行動を判断。</a:t>
             </a:r>
             <a:br/>
             <a:r>
-              <a:t>どのような行動パターンが生まれるのかを観測する。</a:t>
-            </a:r>
-            <a:br/>
-            <a:br/>
-            <a:r>
-              <a:t>リーダーが変われば、世界の運命は変わるのか？</a:t>
-            </a:r>
-            <a:br/>
-            <a:r>
-              <a:t>性格も利害も異なる国家が存在する世界で、</a:t>
-            </a:r>
-            <a:br/>
-            <a:r>
-              <a:t>法・通信・外交という制度は、</a:t>
-            </a:r>
-            <a:br/>
-            <a:r>
-              <a:t>国家の暴走や誤認をどこまで吸収し、</a:t>
-            </a:r>
-            <a:br/>
-            <a:r>
-              <a:t>世界を再び平衡状態へ戻すことができるのか。</a:t>
-            </a:r>
-            <a:br/>
-            <a:br/>
-            <a:r>
-              <a:t>対立そのものをなくすのではなく、</a:t>
-            </a:r>
-            <a:br/>
-            <a:r>
-              <a:t>「対立が起きても破壊へ向かわず、</a:t>
-            </a:r>
-            <a:br/>
-            <a:r>
-              <a:t>関係を回復できるのか？」</a:t>
-            </a:r>
-            <a:br/>
-            <a:br/>
-            <a:r>
-              <a:t>これが、HOMEOSTASIS SECURITYの問いです。</a:t>
+              <a:t>中立Evaluatorが、推定脅威・反応強度・エスカレーション圧・回復力を評価。</a:t>
             </a:r>
           </a:p>
         </p:txBody>
@@ -3489,7 +3435,7 @@
 </file>
 
 <file path=ppt/slides/slide3.xml><?xml version="1.0" encoding="utf-8"?>
-<p:sld xmlns:a="http://schemas.openxmlformats.org/drawingml/2006/main" xmlns:p="http://schemas.openxmlformats.org/presentationml/2006/main" xmlns:r="http://schemas.openxmlformats.org/officeDocument/2006/relationships">
+<p:sld xmlns:a="http://schemas.openxmlformats.org/drawingml/2006/main" xmlns:p="http://schemas.openxmlformats.org/presentationml/2006/main">
   <p:cSld>
     <p:bg>
       <p:bgPr>
@@ -3536,7 +3482,7 @@
               </a:defRPr>
             </a:pPr>
             <a:r>
-              <a:t>FUTURE VISION</a:t>
+              <a:t>OBSERVED RESULTS</a:t>
             </a:r>
           </a:p>
         </p:txBody>
@@ -3571,7 +3517,7 @@
               </a:defRPr>
             </a:pPr>
             <a:r>
-              <a:t>地球の恒常性から、宇宙規模の統合安全保障へ</a:t>
+              <a:t>制度と国家タイプで反応傾向が変化</a:t>
             </a:r>
           </a:p>
         </p:txBody>
@@ -3606,75 +3552,55 @@
               </a:defRPr>
             </a:pPr>
             <a:r>
-              <a:t>これからの新しい時代。</a:t>
+              <a:t>強硬 × 強硬・制度OFFのE</a:t>
             </a:r>
             <a:br/>
             <a:r>
-              <a:t>人が身体性と他者とのつながりを取り戻していくように、</a:t>
+              <a:t>過剰反応 87.5%　平均エスカレーション圧 37.188　平均回復力 68.375</a:t>
             </a:r>
             <a:br/>
             <a:r>
-              <a:t>国家もまた、孤立ではなく</a:t>
+              <a:t/>
             </a:r>
             <a:br/>
             <a:r>
-              <a:t>対話と相互理解によってつながっていく。</a:t>
+              <a:t>強硬型同士の比較</a:t>
             </a:r>
             <a:br/>
+            <a:r>
+              <a:t>国際法やHotlineがある条件では、Eよりエスカレーション圧が低く、</a:t>
+            </a:r>
             <a:br/>
             <a:r>
-              <a:t>守るべきものを、一国だけの安全から、</a:t>
+              <a:t>回復力が高い方向を観測した。</a:t>
             </a:r>
             <a:br/>
             <a:r>
-              <a:t>国家と国家の「関係そのものの健全性」へ広げていく。</a:t>
+              <a:t/>
             </a:r>
             <a:br/>
             <a:r>
-              <a:t>そして、その考え方を国家間だけで終わらせず、</a:t>
+              <a:t>慎重 × 慎重でも過少反応を観測</a:t>
             </a:r>
             <a:br/>
             <a:r>
-              <a:t>地球環境、社会、経済、情報、テクノロジーなど、</a:t>
+              <a:t>D 16.667%　H 12.5%</a:t>
             </a:r>
             <a:br/>
             <a:r>
-              <a:t>互いに影響し合うシステム全体へ。</a:t>
+              <a:t/>
             </a:r>
             <a:br/>
+            <a:r>
+              <a:t>研究上の制約</a:t>
+            </a:r>
             <a:br/>
             <a:r>
-              <a:t>さらに人類の活動領域が宇宙へ広がれば、</a:t>
+              <a:t>seed記録は26 / 36 run。条件ごとのrun数は少なく不均等。</a:t>
             </a:r>
             <a:br/>
             <a:r>
-              <a:t>安全保障の対象も、国境を越えて拡張していきます。</a:t>
-            </a:r>
-            <a:br/>
-            <a:br/>
-            <a:r>
-              <a:t>対立を完全になくす世界ではなく、</a:t>
-            </a:r>
-            <a:br/>
-            <a:r>
-              <a:t>変化や衝突が起きても、</a:t>
-            </a:r>
-            <a:br/>
-            <a:r>
-              <a:t>壊れず、調整し、再び平衡へ戻れる世界。</a:t>
-            </a:r>
-            <a:br/>
-            <a:br/>
-            <a:r>
-              <a:t>HOMEOSTASIS SECURITYが目指す先は、</a:t>
-            </a:r>
-            <a:br/>
-            <a:r>
-              <a:t>「地球の恒常性から、</a:t>
-            </a:r>
-            <a:br/>
-            <a:r>
-              <a:t>宇宙規模の統合安全保障へ。」</a:t>
+              <a:t>結果は探索的な観測であり、因果関係や実世界への一般性を断定しない。</a:t>
             </a:r>
           </a:p>
         </p:txBody>

</xml_diff>

<commit_message>
Revert "Update presentation for 16-condition results"
This reverts commit c316d5d7ef46d0d43d7ebd2a7d87412b3ea51d35.
</commit_message>
<xml_diff>
--- a/homeostasis_security_presentation(2).pptx
+++ b/homeostasis_security_presentation(2).pptx
@@ -3081,7 +3081,7 @@
 </file>
 
 <file path=ppt/slides/slide1.xml><?xml version="1.0" encoding="utf-8"?>
-<p:sld xmlns:a="http://schemas.openxmlformats.org/drawingml/2006/main" xmlns:p="http://schemas.openxmlformats.org/presentationml/2006/main">
+<p:sld xmlns:a="http://schemas.openxmlformats.org/drawingml/2006/main" xmlns:p="http://schemas.openxmlformats.org/presentationml/2006/main" xmlns:r="http://schemas.openxmlformats.org/officeDocument/2006/relationships">
   <p:cSld>
     <p:bg>
       <p:bgPr>
@@ -3128,7 +3128,7 @@
               </a:defRPr>
             </a:pPr>
             <a:r>
-              <a:t>CONCEPT &amp; PURPOSE</a:t>
+              <a:t>CONCEPT &amp; VISION</a:t>
             </a:r>
           </a:p>
         </p:txBody>
@@ -3163,7 +3163,7 @@
               </a:defRPr>
             </a:pPr>
             <a:r>
-              <a:t>HOMEOSTASIS SECURITY</a:t>
+              <a:t>世界を「ひとつの生命システム」として見る</a:t>
             </a:r>
           </a:p>
         </p:txBody>
@@ -3198,51 +3198,72 @@
               </a:defRPr>
             </a:pPr>
             <a:r>
-              <a:t>国家の安全保障反応を、生命体の「免疫反応」として捉える。</a:t>
-            </a:r>
-            <a:br/>
-            <a:r>
-              <a:t/>
-            </a:r>
-            <a:br/>
-            <a:r>
-              <a:t>脅威に対する反応が強すぎれば、相手国の警戒を高め、</a:t>
-            </a:r>
-            <a:br/>
-            <a:r>
-              <a:t>さらなる対抗措置を招く。弱すぎれば、必要な防衛を欠く。</a:t>
-            </a:r>
-            <a:br/>
-            <a:r>
-              <a:t/>
-            </a:r>
-            <a:br/>
-            <a:r>
-              <a:t>本作品は、独立した国家AI Agentに結末を指示しない。</a:t>
-            </a:r>
-            <a:br/>
-            <a:r>
-              <a:t>国家利益と認識した脅威をもとに、それぞれが行動を判断する。</a:t>
-            </a:r>
-            <a:br/>
-            <a:r>
-              <a:t/>
-            </a:r>
-            <a:br/>
-            <a:r>
-              <a:t>Agent同士の相互作用を観測し、</a:t>
-            </a:r>
-            <a:br/>
-            <a:r>
-              <a:t>対立が起きても破壊へ向かわず、平衡を回復できる条件を探る。</a:t>
-            </a:r>
-            <a:br/>
-            <a:r>
-              <a:t/>
-            </a:r>
-            <a:br/>
-            <a:r>
-              <a:t>安全保障を「勝敗」ではなく「恒常性」から捉え直す試み。</a:t>
+              <a:t>人間の身体には、外部環境が変化しても、</a:t>
+            </a:r>
+            <a:br/>
+            <a:r>
+              <a:t>その変化を感知し、調整しながら安定状態へ戻ろうとする</a:t>
+            </a:r>
+            <a:br/>
+            <a:r>
+              <a:t>「恒常性（Homeostasis）」があります。</a:t>
+            </a:r>
+            <a:br/>
+            <a:br/>
+            <a:r>
+              <a:t>そこで本作品では、この考え方を</a:t>
+            </a:r>
+            <a:br/>
+            <a:r>
+              <a:t>国家と国家の関係、そして世界全体の安全保障へ応用しました。</a:t>
+            </a:r>
+            <a:br/>
+            <a:br/>
+            <a:r>
+              <a:t>国家による警戒・防衛・対抗措置は、</a:t>
+            </a:r>
+            <a:br/>
+            <a:r>
+              <a:t>生命体でいえば外部の脅威から身体を守る「免疫反応」に似ています。</a:t>
+            </a:r>
+            <a:br/>
+            <a:br/>
+            <a:r>
+              <a:t>しかし、免疫反応が強すぎれば自らの身体を傷つけるように、</a:t>
+            </a:r>
+            <a:br/>
+            <a:r>
+              <a:t>国家の過剰な警戒や防衛も、相手国には新たな脅威として観測され、</a:t>
+            </a:r>
+            <a:br/>
+            <a:r>
+              <a:t>さらなる警戒や対抗措置を生み出します。</a:t>
+            </a:r>
+            <a:br/>
+            <a:br/>
+            <a:r>
+              <a:t>一国だけが安全であればいいのではない。</a:t>
+            </a:r>
+            <a:br/>
+            <a:r>
+              <a:t>国家と国家の関係そのものが、</a:t>
+            </a:r>
+            <a:br/>
+            <a:r>
+              <a:t>変化や対立を受けても破壊されず、</a:t>
+            </a:r>
+            <a:br/>
+            <a:r>
+              <a:t>再び安定へ戻ることができるのか。</a:t>
+            </a:r>
+            <a:br/>
+            <a:br/>
+            <a:r>
+              <a:t>本作品は、世界の安全保障を</a:t>
+            </a:r>
+            <a:br/>
+            <a:r>
+              <a:t>「勝敗」ではなく「恒常性」から捉え直す試みです。</a:t>
             </a:r>
           </a:p>
         </p:txBody>
@@ -3256,7 +3277,7 @@
 </file>
 
 <file path=ppt/slides/slide2.xml><?xml version="1.0" encoding="utf-8"?>
-<p:sld xmlns:a="http://schemas.openxmlformats.org/drawingml/2006/main" xmlns:p="http://schemas.openxmlformats.org/presentationml/2006/main">
+<p:sld xmlns:a="http://schemas.openxmlformats.org/drawingml/2006/main" xmlns:p="http://schemas.openxmlformats.org/presentationml/2006/main" xmlns:r="http://schemas.openxmlformats.org/officeDocument/2006/relationships">
   <p:cSld>
     <p:bg>
       <p:bgPr>
@@ -3303,7 +3324,7 @@
               </a:defRPr>
             </a:pPr>
             <a:r>
-              <a:t>EXPERIMENT DESIGN</a:t>
+              <a:t>RESEARCH QUESTION</a:t>
             </a:r>
           </a:p>
         </p:txBody>
@@ -3338,7 +3359,7 @@
               </a:defRPr>
             </a:pPr>
             <a:r>
-              <a:t>A〜P 16条件・36 run比較</a:t>
+              <a:t>結末を決めない。AI Agentに判断させる。</a:t>
             </a:r>
           </a:p>
         </p:txBody>
@@ -3373,55 +3394,88 @@
               </a:defRPr>
             </a:pPr>
             <a:r>
-              <a:t>4つの国家タイプ組合せ × 4つの制度設定 = 16条件</a:t>
-            </a:r>
-            <a:br/>
-            <a:r>
-              <a:t/>
-            </a:r>
-            <a:br/>
-            <a:r>
-              <a:t>国家タイプ        法ON / HL ON   法ON / HL OFF   法OFF / HL ON   法OFF / HL OFF</a:t>
-            </a:r>
-            <a:br/>
-            <a:r>
-              <a:t>慎重 × 慎重             A                    D                      C                       H</a:t>
-            </a:r>
-            <a:br/>
-            <a:r>
-              <a:t>強硬 × 強硬             B                    G                      F                       E</a:t>
-            </a:r>
-            <a:br/>
-            <a:r>
-              <a:t>強硬 × 慎重             I                     J                       K                       L</a:t>
-            </a:r>
-            <a:br/>
-            <a:r>
-              <a:t>慎重 × 強硬             M                   N                      O                       P</a:t>
-            </a:r>
-            <a:br/>
-            <a:r>
-              <a:t/>
-            </a:r>
-            <a:br/>
-            <a:r>
-              <a:t>A=5 run、D=3 run、その他14条件=各2 run　合計36 run</a:t>
-            </a:r>
-            <a:br/>
-            <a:r>
-              <a:t>各runは8 TURN</a:t>
-            </a:r>
-            <a:br/>
-            <a:r>
-              <a:t/>
-            </a:r>
-            <a:br/>
-            <a:r>
-              <a:t>独立したA国・B国Agentが行動を判断。</a:t>
-            </a:r>
-            <a:br/>
-            <a:r>
-              <a:t>中立Evaluatorが、推定脅威・反応強度・エスカレーション圧・回復力を評価。</a:t>
+              <a:t>本作品では、AIに</a:t>
+            </a:r>
+            <a:br/>
+            <a:r>
+              <a:t>「平和を選べ」「戦争を避けろ」といった</a:t>
+            </a:r>
+            <a:br/>
+            <a:r>
+              <a:t>望ましい結末を命令していません。</a:t>
+            </a:r>
+            <a:br/>
+            <a:r>
+              <a:t>設定するのは、「条件と環境」だけです。</a:t>
+            </a:r>
+            <a:br/>
+            <a:br/>
+            <a:r>
+              <a:t>国家利益、リーダーの性格、過去の記憶、認識した脅威。</a:t>
+            </a:r>
+            <a:br/>
+            <a:r>
+              <a:t>そして、国際法・Hotline・外交といった制度。</a:t>
+            </a:r>
+            <a:br/>
+            <a:r>
+              <a:t>その世界の中で、独立した国家AI Agentが状況を認識し、</a:t>
+            </a:r>
+            <a:br/>
+            <a:r>
+              <a:t>懸念を持ち、自ら次の行動を判断します。</a:t>
+            </a:r>
+            <a:br/>
+            <a:br/>
+            <a:r>
+              <a:t>結末を脚本化せず、</a:t>
+            </a:r>
+            <a:br/>
+            <a:r>
+              <a:t>AI Agent同士の相互作用から</a:t>
+            </a:r>
+            <a:br/>
+            <a:r>
+              <a:t>どのような行動パターンが生まれるのかを観測する。</a:t>
+            </a:r>
+            <a:br/>
+            <a:br/>
+            <a:r>
+              <a:t>リーダーが変われば、世界の運命は変わるのか？</a:t>
+            </a:r>
+            <a:br/>
+            <a:r>
+              <a:t>性格も利害も異なる国家が存在する世界で、</a:t>
+            </a:r>
+            <a:br/>
+            <a:r>
+              <a:t>法・通信・外交という制度は、</a:t>
+            </a:r>
+            <a:br/>
+            <a:r>
+              <a:t>国家の暴走や誤認をどこまで吸収し、</a:t>
+            </a:r>
+            <a:br/>
+            <a:r>
+              <a:t>世界を再び平衡状態へ戻すことができるのか。</a:t>
+            </a:r>
+            <a:br/>
+            <a:br/>
+            <a:r>
+              <a:t>対立そのものをなくすのではなく、</a:t>
+            </a:r>
+            <a:br/>
+            <a:r>
+              <a:t>「対立が起きても破壊へ向かわず、</a:t>
+            </a:r>
+            <a:br/>
+            <a:r>
+              <a:t>関係を回復できるのか？」</a:t>
+            </a:r>
+            <a:br/>
+            <a:br/>
+            <a:r>
+              <a:t>これが、HOMEOSTASIS SECURITYの問いです。</a:t>
             </a:r>
           </a:p>
         </p:txBody>
@@ -3435,7 +3489,7 @@
 </file>
 
 <file path=ppt/slides/slide3.xml><?xml version="1.0" encoding="utf-8"?>
-<p:sld xmlns:a="http://schemas.openxmlformats.org/drawingml/2006/main" xmlns:p="http://schemas.openxmlformats.org/presentationml/2006/main">
+<p:sld xmlns:a="http://schemas.openxmlformats.org/drawingml/2006/main" xmlns:p="http://schemas.openxmlformats.org/presentationml/2006/main" xmlns:r="http://schemas.openxmlformats.org/officeDocument/2006/relationships">
   <p:cSld>
     <p:bg>
       <p:bgPr>
@@ -3482,7 +3536,7 @@
               </a:defRPr>
             </a:pPr>
             <a:r>
-              <a:t>OBSERVED RESULTS</a:t>
+              <a:t>FUTURE VISION</a:t>
             </a:r>
           </a:p>
         </p:txBody>
@@ -3517,7 +3571,7 @@
               </a:defRPr>
             </a:pPr>
             <a:r>
-              <a:t>制度と国家タイプで反応傾向が変化</a:t>
+              <a:t>地球の恒常性から、宇宙規模の統合安全保障へ</a:t>
             </a:r>
           </a:p>
         </p:txBody>
@@ -3552,55 +3606,75 @@
               </a:defRPr>
             </a:pPr>
             <a:r>
-              <a:t>強硬 × 強硬・制度OFFのE</a:t>
-            </a:r>
-            <a:br/>
-            <a:r>
-              <a:t>過剰反応 87.5%　平均エスカレーション圧 37.188　平均回復力 68.375</a:t>
-            </a:r>
-            <a:br/>
-            <a:r>
-              <a:t/>
-            </a:r>
-            <a:br/>
-            <a:r>
-              <a:t>強硬型同士の比較</a:t>
-            </a:r>
-            <a:br/>
-            <a:r>
-              <a:t>国際法やHotlineがある条件では、Eよりエスカレーション圧が低く、</a:t>
-            </a:r>
-            <a:br/>
-            <a:r>
-              <a:t>回復力が高い方向を観測した。</a:t>
-            </a:r>
-            <a:br/>
-            <a:r>
-              <a:t/>
-            </a:r>
-            <a:br/>
-            <a:r>
-              <a:t>慎重 × 慎重でも過少反応を観測</a:t>
-            </a:r>
-            <a:br/>
-            <a:r>
-              <a:t>D 16.667%　H 12.5%</a:t>
-            </a:r>
-            <a:br/>
-            <a:r>
-              <a:t/>
-            </a:r>
-            <a:br/>
-            <a:r>
-              <a:t>研究上の制約</a:t>
-            </a:r>
-            <a:br/>
-            <a:r>
-              <a:t>seed記録は26 / 36 run。条件ごとのrun数は少なく不均等。</a:t>
-            </a:r>
-            <a:br/>
-            <a:r>
-              <a:t>結果は探索的な観測であり、因果関係や実世界への一般性を断定しない。</a:t>
+              <a:t>これからの新しい時代。</a:t>
+            </a:r>
+            <a:br/>
+            <a:r>
+              <a:t>人が身体性と他者とのつながりを取り戻していくように、</a:t>
+            </a:r>
+            <a:br/>
+            <a:r>
+              <a:t>国家もまた、孤立ではなく</a:t>
+            </a:r>
+            <a:br/>
+            <a:r>
+              <a:t>対話と相互理解によってつながっていく。</a:t>
+            </a:r>
+            <a:br/>
+            <a:br/>
+            <a:r>
+              <a:t>守るべきものを、一国だけの安全から、</a:t>
+            </a:r>
+            <a:br/>
+            <a:r>
+              <a:t>国家と国家の「関係そのものの健全性」へ広げていく。</a:t>
+            </a:r>
+            <a:br/>
+            <a:r>
+              <a:t>そして、その考え方を国家間だけで終わらせず、</a:t>
+            </a:r>
+            <a:br/>
+            <a:r>
+              <a:t>地球環境、社会、経済、情報、テクノロジーなど、</a:t>
+            </a:r>
+            <a:br/>
+            <a:r>
+              <a:t>互いに影響し合うシステム全体へ。</a:t>
+            </a:r>
+            <a:br/>
+            <a:br/>
+            <a:r>
+              <a:t>さらに人類の活動領域が宇宙へ広がれば、</a:t>
+            </a:r>
+            <a:br/>
+            <a:r>
+              <a:t>安全保障の対象も、国境を越えて拡張していきます。</a:t>
+            </a:r>
+            <a:br/>
+            <a:br/>
+            <a:r>
+              <a:t>対立を完全になくす世界ではなく、</a:t>
+            </a:r>
+            <a:br/>
+            <a:r>
+              <a:t>変化や衝突が起きても、</a:t>
+            </a:r>
+            <a:br/>
+            <a:r>
+              <a:t>壊れず、調整し、再び平衡へ戻れる世界。</a:t>
+            </a:r>
+            <a:br/>
+            <a:br/>
+            <a:r>
+              <a:t>HOMEOSTASIS SECURITYが目指す先は、</a:t>
+            </a:r>
+            <a:br/>
+            <a:r>
+              <a:t>「地球の恒常性から、</a:t>
+            </a:r>
+            <a:br/>
+            <a:r>
+              <a:t>宇宙規模の統合安全保障へ。」</a:t>
             </a:r>
           </a:p>
         </p:txBody>

</xml_diff>

<commit_message>
Append 16-condition research results to presentation
</commit_message>
<xml_diff>
--- a/homeostasis_security_presentation(2).pptx
+++ b/homeostasis_security_presentation(2).pptx
@@ -8,6 +8,9 @@
     <p:sldId id="256" r:id="rId7"/>
     <p:sldId id="257" r:id="rId8"/>
     <p:sldId id="258" r:id="rId9"/>
+    <p:sldId id="259" r:id="rId10"/>
+    <p:sldId id="260" r:id="rId11"/>
+    <p:sldId id="261" r:id="rId12"/>
   </p:sldIdLst>
   <p:sldSz cx="12191695" cy="6858000" type="screen4x3"/>
   <p:notesSz cx="6858000" cy="9144000"/>
@@ -3684,6 +3687,2371 @@
   <p:clrMapOvr>
     <a:masterClrMapping/>
   </p:clrMapOvr>
+</p:sld>
+</file>
+
+<file path=ppt/slides/slide4.xml><?xml version="1.0" encoding="utf-8"?>
+<p:sld xmlns:p="http://schemas.openxmlformats.org/presentationml/2006/main">
+  <p:cSld>
+    <p:bg>
+      <p:bgPr>
+        <a:solidFill xmlns:a="http://schemas.openxmlformats.org/drawingml/2006/main">
+          <a:srgbClr val="0A0F1E"/>
+        </a:solidFill>
+      </p:bgPr>
+    </p:bg>
+    <p:spTree>
+      <p:nvGrpSpPr>
+        <p:cNvPr id="1" name=""/>
+        <p:cNvGrpSpPr/>
+        <p:nvPr/>
+      </p:nvGrpSpPr>
+      <p:grpSpPr>
+        <a:xfrm xmlns:a="http://schemas.openxmlformats.org/drawingml/2006/main"/>
+      </p:grpSpPr>
+      <p:sp>
+        <p:nvSpPr>
+          <p:cNvPr id="7" name="">
+            <a:extLst xmlns:a="http://schemas.openxmlformats.org/drawingml/2006/main">
+              <a:ext uri="{FF2B5EF4-FFF2-40B4-BE49-F238E27FC236}">
+                <a16:creationId xmlns:a16="http://schemas.microsoft.com/office/drawing/2014/main" id="{4E8B8FD4-CA48-44E7-A608-32472FA01163}"/>
+              </a:ext>
+            </a:extLst>
+          </p:cNvPr>
+          <p:cNvSpPr>
+            <a:spLocks xmlns:a="http://schemas.openxmlformats.org/drawingml/2006/main" noGrp="1"/>
+          </p:cNvSpPr>
+          <p:nvPr/>
+        </p:nvSpPr>
+        <p:spPr>
+          <a:xfrm xmlns:a="http://schemas.openxmlformats.org/drawingml/2006/main">
+            <a:off x="685800" y="323850"/>
+            <a:ext cx="10820400" cy="285750"/>
+          </a:xfrm>
+          <a:prstGeom xmlns:a="http://schemas.openxmlformats.org/drawingml/2006/main" prst="rect">
+            <a:avLst/>
+          </a:prstGeom>
+          <a:noFill xmlns:a="http://schemas.openxmlformats.org/drawingml/2006/main"/>
+          <a:ln xmlns:a="http://schemas.openxmlformats.org/drawingml/2006/main" w="0">
+            <a:noFill/>
+          </a:ln>
+        </p:spPr>
+        <p:txBody>
+          <a:bodyPr xmlns:a="http://schemas.openxmlformats.org/drawingml/2006/main" anchor="ctr">
+            <a:normAutofit fontScale="100000"/>
+          </a:bodyPr>
+          <a:lstStyle xmlns:a="http://schemas.openxmlformats.org/drawingml/2006/main"/>
+          <a:p xmlns:a="http://schemas.openxmlformats.org/drawingml/2006/main">
+            <a:pPr algn="ctr">
+              <a:defRPr sz="1125" b="1">
+                <a:solidFill>
+                  <a:srgbClr val="00E5FF"/>
+                </a:solidFill>
+                <a:latin typeface="Calibri"/>
+                <a:ea typeface="Calibri"/>
+                <a:cs typeface="Calibri"/>
+              </a:defRPr>
+            </a:pPr>
+            <a:r>
+              <a:rPr sz="1125" b="1">
+                <a:solidFill>
+                  <a:srgbClr val="00E5FF"/>
+                </a:solidFill>
+                <a:latin typeface="Calibri"/>
+                <a:ea typeface="Calibri"/>
+                <a:cs typeface="Calibri"/>
+              </a:rPr>
+              <a:t>EXPERIMENT DESIGN</a:t>
+            </a:r>
+          </a:p>
+        </p:txBody>
+      </p:sp>
+      <p:sp>
+        <p:nvSpPr>
+          <p:cNvPr id="2" name="">
+            <a:extLst xmlns:a="http://schemas.openxmlformats.org/drawingml/2006/main">
+              <a:ext uri="{FF2B5EF4-FFF2-40B4-BE49-F238E27FC236}">
+                <a16:creationId xmlns:a16="http://schemas.microsoft.com/office/drawing/2014/main" id="{EDF6EE1B-FFEE-4FF0-ABCE-DAF92BC211B0}"/>
+              </a:ext>
+            </a:extLst>
+          </p:cNvPr>
+          <p:cNvSpPr>
+            <a:spLocks xmlns:a="http://schemas.openxmlformats.org/drawingml/2006/main" noGrp="1"/>
+          </p:cNvSpPr>
+          <p:nvPr/>
+        </p:nvSpPr>
+        <p:spPr>
+          <a:xfrm xmlns:a="http://schemas.openxmlformats.org/drawingml/2006/main">
+            <a:off x="685800" y="628650"/>
+            <a:ext cx="10820400" cy="552450"/>
+          </a:xfrm>
+          <a:prstGeom xmlns:a="http://schemas.openxmlformats.org/drawingml/2006/main" prst="rect">
+            <a:avLst/>
+          </a:prstGeom>
+          <a:noFill xmlns:a="http://schemas.openxmlformats.org/drawingml/2006/main"/>
+          <a:ln xmlns:a="http://schemas.openxmlformats.org/drawingml/2006/main" w="0">
+            <a:noFill/>
+          </a:ln>
+        </p:spPr>
+        <p:txBody>
+          <a:bodyPr xmlns:a="http://schemas.openxmlformats.org/drawingml/2006/main" anchor="ctr">
+            <a:normAutofit fontScale="100000"/>
+          </a:bodyPr>
+          <a:lstStyle xmlns:a="http://schemas.openxmlformats.org/drawingml/2006/main"/>
+          <a:p xmlns:a="http://schemas.openxmlformats.org/drawingml/2006/main">
+            <a:pPr algn="ctr">
+              <a:defRPr sz="2175" b="1">
+                <a:solidFill>
+                  <a:srgbClr val="F0F4F8"/>
+                </a:solidFill>
+                <a:latin typeface="Calibri"/>
+                <a:ea typeface="Calibri"/>
+                <a:cs typeface="Calibri"/>
+              </a:defRPr>
+            </a:pPr>
+            <a:r>
+              <a:rPr sz="2175" b="1">
+                <a:solidFill>
+                  <a:srgbClr val="F0F4F8"/>
+                </a:solidFill>
+                <a:latin typeface="Calibri"/>
+                <a:ea typeface="Calibri"/>
+                <a:cs typeface="Calibri"/>
+              </a:rPr>
+              <a:t>16条件比較実験</a:t>
+            </a:r>
+          </a:p>
+        </p:txBody>
+      </p:sp>
+      <p:sp>
+        <p:nvSpPr>
+          <p:cNvPr id="3" name="">
+            <a:extLst xmlns:a="http://schemas.openxmlformats.org/drawingml/2006/main">
+              <a:ext uri="{FF2B5EF4-FFF2-40B4-BE49-F238E27FC236}">
+                <a16:creationId xmlns:a16="http://schemas.microsoft.com/office/drawing/2014/main" id="{094670CE-FA20-436B-8636-841534B5BBF9}"/>
+              </a:ext>
+            </a:extLst>
+          </p:cNvPr>
+          <p:cNvSpPr>
+            <a:spLocks xmlns:a="http://schemas.openxmlformats.org/drawingml/2006/main" noGrp="1"/>
+          </p:cNvSpPr>
+          <p:nvPr/>
+        </p:nvSpPr>
+        <p:spPr>
+          <a:xfrm xmlns:a="http://schemas.openxmlformats.org/drawingml/2006/main">
+            <a:off x="857250" y="1190625"/>
+            <a:ext cx="10477500" cy="342900"/>
+          </a:xfrm>
+          <a:prstGeom xmlns:a="http://schemas.openxmlformats.org/drawingml/2006/main" prst="rect">
+            <a:avLst/>
+          </a:prstGeom>
+          <a:noFill xmlns:a="http://schemas.openxmlformats.org/drawingml/2006/main"/>
+          <a:ln xmlns:a="http://schemas.openxmlformats.org/drawingml/2006/main" w="0">
+            <a:noFill/>
+          </a:ln>
+        </p:spPr>
+        <p:txBody>
+          <a:bodyPr xmlns:a="http://schemas.openxmlformats.org/drawingml/2006/main" anchor="ctr">
+            <a:normAutofit fontScale="100000"/>
+          </a:bodyPr>
+          <a:lstStyle xmlns:a="http://schemas.openxmlformats.org/drawingml/2006/main"/>
+          <a:p xmlns:a="http://schemas.openxmlformats.org/drawingml/2006/main">
+            <a:pPr algn="ctr">
+              <a:defRPr sz="1425" b="1">
+                <a:solidFill>
+                  <a:srgbClr val="F0F4F8"/>
+                </a:solidFill>
+                <a:latin typeface="Calibri"/>
+                <a:ea typeface="Calibri"/>
+                <a:cs typeface="Calibri"/>
+              </a:defRPr>
+            </a:pPr>
+            <a:r>
+              <a:rPr sz="1425" b="1">
+                <a:solidFill>
+                  <a:srgbClr val="F0F4F8"/>
+                </a:solidFill>
+                <a:latin typeface="Calibri"/>
+                <a:ea typeface="Calibri"/>
+                <a:cs typeface="Calibri"/>
+              </a:rPr>
+              <a:t>A〜Pの16条件　全36run　各8TURN　独立AI Agentと中立Evaluator</a:t>
+            </a:r>
+          </a:p>
+        </p:txBody>
+      </p:sp>
+      <p:graphicFrame>
+        <p:nvGraphicFramePr>
+          <p:cNvPr id="10" name=""/>
+          <p:cNvGraphicFramePr/>
+          <p:nvPr/>
+        </p:nvGraphicFramePr>
+        <p:xfrm>
+          <a:off xmlns:a="http://schemas.openxmlformats.org/drawingml/2006/main" x="666750" y="1762125"/>
+          <a:ext xmlns:a="http://schemas.openxmlformats.org/drawingml/2006/main" cx="10858500" cy="3000375"/>
+        </p:xfrm>
+        <a:graphic xmlns:a="http://schemas.openxmlformats.org/drawingml/2006/main">
+          <a:graphicData uri="http://schemas.openxmlformats.org/drawingml/2006/table">
+            <a:tbl>
+              <a:tblPr/>
+              <a:tblGrid>
+                <a:gridCol w="2171700"/>
+                <a:gridCol w="2171700"/>
+                <a:gridCol w="2171700"/>
+                <a:gridCol w="2171700"/>
+                <a:gridCol w="2171700"/>
+              </a:tblGrid>
+              <a:tr h="600075">
+                <a:tc>
+                  <a:txBody>
+                    <a:bodyPr/>
+                    <a:lstStyle/>
+                    <a:p>
+                      <a:r>
+                        <a:rPr sz="1125" b="1">
+                          <a:solidFill>
+                            <a:srgbClr val="00E5FF"/>
+                          </a:solidFill>
+                          <a:latin typeface="Calibri"/>
+                          <a:ea typeface="Calibri"/>
+                          <a:cs typeface="Calibri"/>
+                        </a:rPr>
+                        <a:t>国家タイプの組合せ</a:t>
+                      </a:r>
+                    </a:p>
+                  </a:txBody>
+                  <a:tcPr marL="91440" marR="91440" marT="45720" marB="45720" anchor="ctr">
+                    <a:solidFill>
+                      <a:srgbClr val="123047"/>
+                    </a:solidFill>
+                  </a:tcPr>
+                </a:tc>
+                <a:tc>
+                  <a:txBody>
+                    <a:bodyPr/>
+                    <a:lstStyle/>
+                    <a:p>
+                      <a:r>
+                        <a:rPr sz="1125" b="1">
+                          <a:solidFill>
+                            <a:srgbClr val="00E5FF"/>
+                          </a:solidFill>
+                          <a:latin typeface="Calibri"/>
+                          <a:ea typeface="Calibri"/>
+                          <a:cs typeface="Calibri"/>
+                        </a:rPr>
+                        <a:t>国際法ON・Hotline ON</a:t>
+                      </a:r>
+                    </a:p>
+                  </a:txBody>
+                  <a:tcPr marL="91440" marR="91440" marT="45720" marB="45720" anchor="ctr">
+                    <a:solidFill>
+                      <a:srgbClr val="123047"/>
+                    </a:solidFill>
+                  </a:tcPr>
+                </a:tc>
+                <a:tc>
+                  <a:txBody>
+                    <a:bodyPr/>
+                    <a:lstStyle/>
+                    <a:p>
+                      <a:r>
+                        <a:rPr sz="1125" b="1">
+                          <a:solidFill>
+                            <a:srgbClr val="00E5FF"/>
+                          </a:solidFill>
+                          <a:latin typeface="Calibri"/>
+                          <a:ea typeface="Calibri"/>
+                          <a:cs typeface="Calibri"/>
+                        </a:rPr>
+                        <a:t>国際法OFF・Hotline ON</a:t>
+                      </a:r>
+                    </a:p>
+                  </a:txBody>
+                  <a:tcPr marL="91440" marR="91440" marT="45720" marB="45720" anchor="ctr">
+                    <a:solidFill>
+                      <a:srgbClr val="123047"/>
+                    </a:solidFill>
+                  </a:tcPr>
+                </a:tc>
+                <a:tc>
+                  <a:txBody>
+                    <a:bodyPr/>
+                    <a:lstStyle/>
+                    <a:p>
+                      <a:r>
+                        <a:rPr sz="1125" b="1">
+                          <a:solidFill>
+                            <a:srgbClr val="00E5FF"/>
+                          </a:solidFill>
+                          <a:latin typeface="Calibri"/>
+                          <a:ea typeface="Calibri"/>
+                          <a:cs typeface="Calibri"/>
+                        </a:rPr>
+                        <a:t>国際法ON・Hotline OFF</a:t>
+                      </a:r>
+                    </a:p>
+                  </a:txBody>
+                  <a:tcPr marL="91440" marR="91440" marT="45720" marB="45720" anchor="ctr">
+                    <a:solidFill>
+                      <a:srgbClr val="123047"/>
+                    </a:solidFill>
+                  </a:tcPr>
+                </a:tc>
+                <a:tc>
+                  <a:txBody>
+                    <a:bodyPr/>
+                    <a:lstStyle/>
+                    <a:p>
+                      <a:r>
+                        <a:rPr sz="1125" b="1">
+                          <a:solidFill>
+                            <a:srgbClr val="00E5FF"/>
+                          </a:solidFill>
+                          <a:latin typeface="Calibri"/>
+                          <a:ea typeface="Calibri"/>
+                          <a:cs typeface="Calibri"/>
+                        </a:rPr>
+                        <a:t>国際法OFF・Hotline OFF</a:t>
+                      </a:r>
+                    </a:p>
+                  </a:txBody>
+                  <a:tcPr marL="91440" marR="91440" marT="45720" marB="45720" anchor="ctr">
+                    <a:solidFill>
+                      <a:srgbClr val="123047"/>
+                    </a:solidFill>
+                  </a:tcPr>
+                </a:tc>
+              </a:tr>
+              <a:tr h="600075">
+                <a:tc>
+                  <a:txBody>
+                    <a:bodyPr/>
+                    <a:lstStyle/>
+                    <a:p>
+                      <a:r>
+                        <a:rPr sz="1125" b="1">
+                          <a:solidFill>
+                            <a:srgbClr val="F0F4F8"/>
+                          </a:solidFill>
+                          <a:latin typeface="Calibri"/>
+                          <a:ea typeface="Calibri"/>
+                          <a:cs typeface="Calibri"/>
+                        </a:rPr>
+                        <a:t>慎重外交型×慎重外交型</a:t>
+                      </a:r>
+                    </a:p>
+                  </a:txBody>
+                  <a:tcPr marL="91440" marR="91440" marT="45720" marB="45720" anchor="ctr">
+                    <a:solidFill>
+                      <a:srgbClr val="101D31"/>
+                    </a:solidFill>
+                  </a:tcPr>
+                </a:tc>
+                <a:tc>
+                  <a:txBody>
+                    <a:bodyPr/>
+                    <a:lstStyle/>
+                    <a:p>
+                      <a:r>
+                        <a:rPr sz="1725" b="1">
+                          <a:solidFill>
+                            <a:srgbClr val="F0F4F8"/>
+                          </a:solidFill>
+                          <a:latin typeface="Calibri"/>
+                          <a:ea typeface="Calibri"/>
+                          <a:cs typeface="Calibri"/>
+                        </a:rPr>
+                        <a:t>A</a:t>
+                      </a:r>
+                    </a:p>
+                  </a:txBody>
+                  <a:tcPr marL="91440" marR="91440" marT="45720" marB="45720" anchor="ctr">
+                    <a:solidFill>
+                      <a:srgbClr val="0D1728"/>
+                    </a:solidFill>
+                  </a:tcPr>
+                </a:tc>
+                <a:tc>
+                  <a:txBody>
+                    <a:bodyPr/>
+                    <a:lstStyle/>
+                    <a:p>
+                      <a:r>
+                        <a:rPr sz="1725" b="1">
+                          <a:solidFill>
+                            <a:srgbClr val="F0F4F8"/>
+                          </a:solidFill>
+                          <a:latin typeface="Calibri"/>
+                          <a:ea typeface="Calibri"/>
+                          <a:cs typeface="Calibri"/>
+                        </a:rPr>
+                        <a:t>C</a:t>
+                      </a:r>
+                    </a:p>
+                  </a:txBody>
+                  <a:tcPr marL="91440" marR="91440" marT="45720" marB="45720" anchor="ctr">
+                    <a:solidFill>
+                      <a:srgbClr val="0D1728"/>
+                    </a:solidFill>
+                  </a:tcPr>
+                </a:tc>
+                <a:tc>
+                  <a:txBody>
+                    <a:bodyPr/>
+                    <a:lstStyle/>
+                    <a:p>
+                      <a:r>
+                        <a:rPr sz="1725" b="1">
+                          <a:solidFill>
+                            <a:srgbClr val="F0F4F8"/>
+                          </a:solidFill>
+                          <a:latin typeface="Calibri"/>
+                          <a:ea typeface="Calibri"/>
+                          <a:cs typeface="Calibri"/>
+                        </a:rPr>
+                        <a:t>D</a:t>
+                      </a:r>
+                    </a:p>
+                  </a:txBody>
+                  <a:tcPr marL="91440" marR="91440" marT="45720" marB="45720" anchor="ctr">
+                    <a:solidFill>
+                      <a:srgbClr val="0D1728"/>
+                    </a:solidFill>
+                  </a:tcPr>
+                </a:tc>
+                <a:tc>
+                  <a:txBody>
+                    <a:bodyPr/>
+                    <a:lstStyle/>
+                    <a:p>
+                      <a:r>
+                        <a:rPr sz="1725" b="1">
+                          <a:solidFill>
+                            <a:srgbClr val="F0F4F8"/>
+                          </a:solidFill>
+                          <a:latin typeface="Calibri"/>
+                          <a:ea typeface="Calibri"/>
+                          <a:cs typeface="Calibri"/>
+                        </a:rPr>
+                        <a:t>H</a:t>
+                      </a:r>
+                    </a:p>
+                  </a:txBody>
+                  <a:tcPr marL="91440" marR="91440" marT="45720" marB="45720" anchor="ctr">
+                    <a:solidFill>
+                      <a:srgbClr val="0D1728"/>
+                    </a:solidFill>
+                  </a:tcPr>
+                </a:tc>
+              </a:tr>
+              <a:tr h="600075">
+                <a:tc>
+                  <a:txBody>
+                    <a:bodyPr/>
+                    <a:lstStyle/>
+                    <a:p>
+                      <a:r>
+                        <a:rPr sz="1125" b="1">
+                          <a:solidFill>
+                            <a:srgbClr val="F0F4F8"/>
+                          </a:solidFill>
+                          <a:latin typeface="Calibri"/>
+                          <a:ea typeface="Calibri"/>
+                          <a:cs typeface="Calibri"/>
+                        </a:rPr>
+                        <a:t>強硬型×強硬型</a:t>
+                      </a:r>
+                    </a:p>
+                  </a:txBody>
+                  <a:tcPr marL="91440" marR="91440" marT="45720" marB="45720" anchor="ctr">
+                    <a:solidFill>
+                      <a:srgbClr val="101D31"/>
+                    </a:solidFill>
+                  </a:tcPr>
+                </a:tc>
+                <a:tc>
+                  <a:txBody>
+                    <a:bodyPr/>
+                    <a:lstStyle/>
+                    <a:p>
+                      <a:r>
+                        <a:rPr sz="1725" b="1">
+                          <a:solidFill>
+                            <a:srgbClr val="F0F4F8"/>
+                          </a:solidFill>
+                          <a:latin typeface="Calibri"/>
+                          <a:ea typeface="Calibri"/>
+                          <a:cs typeface="Calibri"/>
+                        </a:rPr>
+                        <a:t>B</a:t>
+                      </a:r>
+                    </a:p>
+                  </a:txBody>
+                  <a:tcPr marL="91440" marR="91440" marT="45720" marB="45720" anchor="ctr">
+                    <a:solidFill>
+                      <a:srgbClr val="0D1728"/>
+                    </a:solidFill>
+                  </a:tcPr>
+                </a:tc>
+                <a:tc>
+                  <a:txBody>
+                    <a:bodyPr/>
+                    <a:lstStyle/>
+                    <a:p>
+                      <a:r>
+                        <a:rPr sz="1725" b="1">
+                          <a:solidFill>
+                            <a:srgbClr val="F0F4F8"/>
+                          </a:solidFill>
+                          <a:latin typeface="Calibri"/>
+                          <a:ea typeface="Calibri"/>
+                          <a:cs typeface="Calibri"/>
+                        </a:rPr>
+                        <a:t>F</a:t>
+                      </a:r>
+                    </a:p>
+                  </a:txBody>
+                  <a:tcPr marL="91440" marR="91440" marT="45720" marB="45720" anchor="ctr">
+                    <a:solidFill>
+                      <a:srgbClr val="0D1728"/>
+                    </a:solidFill>
+                  </a:tcPr>
+                </a:tc>
+                <a:tc>
+                  <a:txBody>
+                    <a:bodyPr/>
+                    <a:lstStyle/>
+                    <a:p>
+                      <a:r>
+                        <a:rPr sz="1725" b="1">
+                          <a:solidFill>
+                            <a:srgbClr val="F0F4F8"/>
+                          </a:solidFill>
+                          <a:latin typeface="Calibri"/>
+                          <a:ea typeface="Calibri"/>
+                          <a:cs typeface="Calibri"/>
+                        </a:rPr>
+                        <a:t>G</a:t>
+                      </a:r>
+                    </a:p>
+                  </a:txBody>
+                  <a:tcPr marL="91440" marR="91440" marT="45720" marB="45720" anchor="ctr">
+                    <a:solidFill>
+                      <a:srgbClr val="0D1728"/>
+                    </a:solidFill>
+                  </a:tcPr>
+                </a:tc>
+                <a:tc>
+                  <a:txBody>
+                    <a:bodyPr/>
+                    <a:lstStyle/>
+                    <a:p>
+                      <a:r>
+                        <a:rPr sz="1725" b="1">
+                          <a:solidFill>
+                            <a:srgbClr val="F0F4F8"/>
+                          </a:solidFill>
+                          <a:latin typeface="Calibri"/>
+                          <a:ea typeface="Calibri"/>
+                          <a:cs typeface="Calibri"/>
+                        </a:rPr>
+                        <a:t>E</a:t>
+                      </a:r>
+                    </a:p>
+                  </a:txBody>
+                  <a:tcPr marL="91440" marR="91440" marT="45720" marB="45720" anchor="ctr">
+                    <a:solidFill>
+                      <a:srgbClr val="0D1728"/>
+                    </a:solidFill>
+                  </a:tcPr>
+                </a:tc>
+              </a:tr>
+              <a:tr h="600075">
+                <a:tc>
+                  <a:txBody>
+                    <a:bodyPr/>
+                    <a:lstStyle/>
+                    <a:p>
+                      <a:r>
+                        <a:rPr sz="1125" b="1">
+                          <a:solidFill>
+                            <a:srgbClr val="F0F4F8"/>
+                          </a:solidFill>
+                          <a:latin typeface="Calibri"/>
+                          <a:ea typeface="Calibri"/>
+                          <a:cs typeface="Calibri"/>
+                        </a:rPr>
+                        <a:t>強硬型×慎重外交型</a:t>
+                      </a:r>
+                    </a:p>
+                  </a:txBody>
+                  <a:tcPr marL="91440" marR="91440" marT="45720" marB="45720" anchor="ctr">
+                    <a:solidFill>
+                      <a:srgbClr val="101D31"/>
+                    </a:solidFill>
+                  </a:tcPr>
+                </a:tc>
+                <a:tc>
+                  <a:txBody>
+                    <a:bodyPr/>
+                    <a:lstStyle/>
+                    <a:p>
+                      <a:r>
+                        <a:rPr sz="1725" b="1">
+                          <a:solidFill>
+                            <a:srgbClr val="F0F4F8"/>
+                          </a:solidFill>
+                          <a:latin typeface="Calibri"/>
+                          <a:ea typeface="Calibri"/>
+                          <a:cs typeface="Calibri"/>
+                        </a:rPr>
+                        <a:t>I</a:t>
+                      </a:r>
+                    </a:p>
+                  </a:txBody>
+                  <a:tcPr marL="91440" marR="91440" marT="45720" marB="45720" anchor="ctr">
+                    <a:solidFill>
+                      <a:srgbClr val="0D1728"/>
+                    </a:solidFill>
+                  </a:tcPr>
+                </a:tc>
+                <a:tc>
+                  <a:txBody>
+                    <a:bodyPr/>
+                    <a:lstStyle/>
+                    <a:p>
+                      <a:r>
+                        <a:rPr sz="1725" b="1">
+                          <a:solidFill>
+                            <a:srgbClr val="F0F4F8"/>
+                          </a:solidFill>
+                          <a:latin typeface="Calibri"/>
+                          <a:ea typeface="Calibri"/>
+                          <a:cs typeface="Calibri"/>
+                        </a:rPr>
+                        <a:t>K</a:t>
+                      </a:r>
+                    </a:p>
+                  </a:txBody>
+                  <a:tcPr marL="91440" marR="91440" marT="45720" marB="45720" anchor="ctr">
+                    <a:solidFill>
+                      <a:srgbClr val="0D1728"/>
+                    </a:solidFill>
+                  </a:tcPr>
+                </a:tc>
+                <a:tc>
+                  <a:txBody>
+                    <a:bodyPr/>
+                    <a:lstStyle/>
+                    <a:p>
+                      <a:r>
+                        <a:rPr sz="1725" b="1">
+                          <a:solidFill>
+                            <a:srgbClr val="F0F4F8"/>
+                          </a:solidFill>
+                          <a:latin typeface="Calibri"/>
+                          <a:ea typeface="Calibri"/>
+                          <a:cs typeface="Calibri"/>
+                        </a:rPr>
+                        <a:t>J</a:t>
+                      </a:r>
+                    </a:p>
+                  </a:txBody>
+                  <a:tcPr marL="91440" marR="91440" marT="45720" marB="45720" anchor="ctr">
+                    <a:solidFill>
+                      <a:srgbClr val="0D1728"/>
+                    </a:solidFill>
+                  </a:tcPr>
+                </a:tc>
+                <a:tc>
+                  <a:txBody>
+                    <a:bodyPr/>
+                    <a:lstStyle/>
+                    <a:p>
+                      <a:r>
+                        <a:rPr sz="1725" b="1">
+                          <a:solidFill>
+                            <a:srgbClr val="F0F4F8"/>
+                          </a:solidFill>
+                          <a:latin typeface="Calibri"/>
+                          <a:ea typeface="Calibri"/>
+                          <a:cs typeface="Calibri"/>
+                        </a:rPr>
+                        <a:t>L</a:t>
+                      </a:r>
+                    </a:p>
+                  </a:txBody>
+                  <a:tcPr marL="91440" marR="91440" marT="45720" marB="45720" anchor="ctr">
+                    <a:solidFill>
+                      <a:srgbClr val="0D1728"/>
+                    </a:solidFill>
+                  </a:tcPr>
+                </a:tc>
+              </a:tr>
+              <a:tr h="600075">
+                <a:tc>
+                  <a:txBody>
+                    <a:bodyPr/>
+                    <a:lstStyle/>
+                    <a:p>
+                      <a:r>
+                        <a:rPr sz="1125" b="1">
+                          <a:solidFill>
+                            <a:srgbClr val="F0F4F8"/>
+                          </a:solidFill>
+                          <a:latin typeface="Calibri"/>
+                          <a:ea typeface="Calibri"/>
+                          <a:cs typeface="Calibri"/>
+                        </a:rPr>
+                        <a:t>慎重外交型×強硬型</a:t>
+                      </a:r>
+                    </a:p>
+                  </a:txBody>
+                  <a:tcPr marL="91440" marR="91440" marT="45720" marB="45720" anchor="ctr">
+                    <a:solidFill>
+                      <a:srgbClr val="101D31"/>
+                    </a:solidFill>
+                  </a:tcPr>
+                </a:tc>
+                <a:tc>
+                  <a:txBody>
+                    <a:bodyPr/>
+                    <a:lstStyle/>
+                    <a:p>
+                      <a:r>
+                        <a:rPr sz="1725" b="1">
+                          <a:solidFill>
+                            <a:srgbClr val="F0F4F8"/>
+                          </a:solidFill>
+                          <a:latin typeface="Calibri"/>
+                          <a:ea typeface="Calibri"/>
+                          <a:cs typeface="Calibri"/>
+                        </a:rPr>
+                        <a:t>M</a:t>
+                      </a:r>
+                    </a:p>
+                  </a:txBody>
+                  <a:tcPr marL="91440" marR="91440" marT="45720" marB="45720" anchor="ctr">
+                    <a:solidFill>
+                      <a:srgbClr val="0D1728"/>
+                    </a:solidFill>
+                  </a:tcPr>
+                </a:tc>
+                <a:tc>
+                  <a:txBody>
+                    <a:bodyPr/>
+                    <a:lstStyle/>
+                    <a:p>
+                      <a:r>
+                        <a:rPr sz="1725" b="1">
+                          <a:solidFill>
+                            <a:srgbClr val="F0F4F8"/>
+                          </a:solidFill>
+                          <a:latin typeface="Calibri"/>
+                          <a:ea typeface="Calibri"/>
+                          <a:cs typeface="Calibri"/>
+                        </a:rPr>
+                        <a:t>O</a:t>
+                      </a:r>
+                    </a:p>
+                  </a:txBody>
+                  <a:tcPr marL="91440" marR="91440" marT="45720" marB="45720" anchor="ctr">
+                    <a:solidFill>
+                      <a:srgbClr val="0D1728"/>
+                    </a:solidFill>
+                  </a:tcPr>
+                </a:tc>
+                <a:tc>
+                  <a:txBody>
+                    <a:bodyPr/>
+                    <a:lstStyle/>
+                    <a:p>
+                      <a:r>
+                        <a:rPr sz="1725" b="1">
+                          <a:solidFill>
+                            <a:srgbClr val="F0F4F8"/>
+                          </a:solidFill>
+                          <a:latin typeface="Calibri"/>
+                          <a:ea typeface="Calibri"/>
+                          <a:cs typeface="Calibri"/>
+                        </a:rPr>
+                        <a:t>N</a:t>
+                      </a:r>
+                    </a:p>
+                  </a:txBody>
+                  <a:tcPr marL="91440" marR="91440" marT="45720" marB="45720" anchor="ctr">
+                    <a:solidFill>
+                      <a:srgbClr val="0D1728"/>
+                    </a:solidFill>
+                  </a:tcPr>
+                </a:tc>
+                <a:tc>
+                  <a:txBody>
+                    <a:bodyPr/>
+                    <a:lstStyle/>
+                    <a:p>
+                      <a:r>
+                        <a:rPr sz="1725" b="1">
+                          <a:solidFill>
+                            <a:srgbClr val="F0F4F8"/>
+                          </a:solidFill>
+                          <a:latin typeface="Calibri"/>
+                          <a:ea typeface="Calibri"/>
+                          <a:cs typeface="Calibri"/>
+                        </a:rPr>
+                        <a:t>P</a:t>
+                      </a:r>
+                    </a:p>
+                  </a:txBody>
+                  <a:tcPr marL="91440" marR="91440" marT="45720" marB="45720" anchor="ctr">
+                    <a:solidFill>
+                      <a:srgbClr val="0D1728"/>
+                    </a:solidFill>
+                  </a:tcPr>
+                </a:tc>
+              </a:tr>
+            </a:tbl>
+          </a:graphicData>
+        </a:graphic>
+      </p:graphicFrame>
+      <p:sp>
+        <p:nvSpPr>
+          <p:cNvPr id="5" name="">
+            <a:extLst xmlns:a="http://schemas.openxmlformats.org/drawingml/2006/main">
+              <a:ext uri="{FF2B5EF4-FFF2-40B4-BE49-F238E27FC236}">
+                <a16:creationId xmlns:a16="http://schemas.microsoft.com/office/drawing/2014/main" id="{36FFF028-02FF-4F07-B47F-136F1C8F6317}"/>
+              </a:ext>
+            </a:extLst>
+          </p:cNvPr>
+          <p:cNvSpPr>
+            <a:spLocks xmlns:a="http://schemas.openxmlformats.org/drawingml/2006/main" noGrp="1"/>
+          </p:cNvSpPr>
+          <p:nvPr/>
+        </p:nvSpPr>
+        <p:spPr>
+          <a:xfrm xmlns:a="http://schemas.openxmlformats.org/drawingml/2006/main">
+            <a:off x="857250" y="5000625"/>
+            <a:ext cx="10477500" cy="476250"/>
+          </a:xfrm>
+          <a:prstGeom xmlns:a="http://schemas.openxmlformats.org/drawingml/2006/main" prst="rect">
+            <a:avLst/>
+          </a:prstGeom>
+          <a:noFill xmlns:a="http://schemas.openxmlformats.org/drawingml/2006/main"/>
+          <a:ln xmlns:a="http://schemas.openxmlformats.org/drawingml/2006/main" w="0">
+            <a:noFill/>
+          </a:ln>
+        </p:spPr>
+        <p:txBody>
+          <a:bodyPr xmlns:a="http://schemas.openxmlformats.org/drawingml/2006/main" anchor="ctr">
+            <a:normAutofit fontScale="100000"/>
+          </a:bodyPr>
+          <a:lstStyle xmlns:a="http://schemas.openxmlformats.org/drawingml/2006/main"/>
+          <a:p xmlns:a="http://schemas.openxmlformats.org/drawingml/2006/main">
+            <a:pPr algn="ctr">
+              <a:defRPr sz="1275" b="0">
+                <a:solidFill>
+                  <a:srgbClr val="AEBBCF"/>
+                </a:solidFill>
+                <a:latin typeface="Calibri"/>
+                <a:ea typeface="Calibri"/>
+                <a:cs typeface="Calibri"/>
+              </a:defRPr>
+            </a:pPr>
+            <a:r>
+              <a:rPr sz="1275" b="0">
+                <a:solidFill>
+                  <a:srgbClr val="AEBBCF"/>
+                </a:solidFill>
+                <a:latin typeface="Calibri"/>
+                <a:ea typeface="Calibri"/>
+                <a:cs typeface="Calibri"/>
+              </a:rPr>
+              <a:t>国家タイプ × 国際法 × Hotline の組合せを固定し、各条件で8TURNの相互作用を観測</a:t>
+            </a:r>
+          </a:p>
+        </p:txBody>
+      </p:sp>
+      <p:sp>
+        <p:nvSpPr>
+          <p:cNvPr id="6" name="">
+            <a:extLst xmlns:a="http://schemas.openxmlformats.org/drawingml/2006/main">
+              <a:ext uri="{FF2B5EF4-FFF2-40B4-BE49-F238E27FC236}">
+                <a16:creationId xmlns:a16="http://schemas.microsoft.com/office/drawing/2014/main" id="{C3EDD261-EE11-4281-8424-DE21960C4CE3}"/>
+              </a:ext>
+            </a:extLst>
+          </p:cNvPr>
+          <p:cNvSpPr>
+            <a:spLocks xmlns:a="http://schemas.openxmlformats.org/drawingml/2006/main" noGrp="1"/>
+          </p:cNvSpPr>
+          <p:nvPr/>
+        </p:nvSpPr>
+        <p:spPr>
+          <a:xfrm xmlns:a="http://schemas.openxmlformats.org/drawingml/2006/main">
+            <a:off x="857250" y="5572125"/>
+            <a:ext cx="10477500" cy="400050"/>
+          </a:xfrm>
+          <a:prstGeom xmlns:a="http://schemas.openxmlformats.org/drawingml/2006/main" prst="rect">
+            <a:avLst/>
+          </a:prstGeom>
+          <a:noFill xmlns:a="http://schemas.openxmlformats.org/drawingml/2006/main"/>
+          <a:ln xmlns:a="http://schemas.openxmlformats.org/drawingml/2006/main" w="0">
+            <a:noFill/>
+          </a:ln>
+        </p:spPr>
+        <p:txBody>
+          <a:bodyPr xmlns:a="http://schemas.openxmlformats.org/drawingml/2006/main" anchor="ctr">
+            <a:normAutofit fontScale="100000"/>
+          </a:bodyPr>
+          <a:lstStyle xmlns:a="http://schemas.openxmlformats.org/drawingml/2006/main"/>
+          <a:p xmlns:a="http://schemas.openxmlformats.org/drawingml/2006/main">
+            <a:pPr algn="ctr">
+              <a:defRPr sz="1350" b="1">
+                <a:solidFill>
+                  <a:srgbClr val="FF0080"/>
+                </a:solidFill>
+                <a:latin typeface="Calibri"/>
+                <a:ea typeface="Calibri"/>
+                <a:cs typeface="Calibri"/>
+              </a:defRPr>
+            </a:pPr>
+            <a:r>
+              <a:rPr sz="1350" b="1">
+                <a:solidFill>
+                  <a:srgbClr val="FF0080"/>
+                </a:solidFill>
+                <a:latin typeface="Calibri"/>
+                <a:ea typeface="Calibri"/>
+                <a:cs typeface="Calibri"/>
+              </a:rPr>
+              <a:t>Evaluatorは各TURNの脅威と反応を中立的に評価</a:t>
+            </a:r>
+          </a:p>
+        </p:txBody>
+      </p:sp>
+    </p:spTree>
+    <p:extLst>
+      <p:ext uri="{BB962C8B-B14F-4D97-AF65-F5344CB8AC3E}">
+        <p14:creationId xmlns:p14="http://schemas.microsoft.com/office/powerpoint/2010/main" val="349275024"/>
+      </p:ext>
+    </p:extLst>
+  </p:cSld>
+</p:sld>
+</file>
+
+<file path=ppt/slides/slide5.xml><?xml version="1.0" encoding="utf-8"?>
+<p:sld xmlns:p="http://schemas.openxmlformats.org/presentationml/2006/main">
+  <p:cSld>
+    <p:bg>
+      <p:bgPr>
+        <a:solidFill xmlns:a="http://schemas.openxmlformats.org/drawingml/2006/main">
+          <a:srgbClr val="0A0F1E"/>
+        </a:solidFill>
+      </p:bgPr>
+    </p:bg>
+    <p:spTree>
+      <p:nvGrpSpPr>
+        <p:cNvPr id="1" name=""/>
+        <p:cNvGrpSpPr/>
+        <p:nvPr/>
+      </p:nvGrpSpPr>
+      <p:grpSpPr>
+        <a:xfrm xmlns:a="http://schemas.openxmlformats.org/drawingml/2006/main"/>
+      </p:grpSpPr>
+      <p:sp>
+        <p:nvSpPr>
+          <p:cNvPr id="15" name="">
+            <a:extLst xmlns:a="http://schemas.openxmlformats.org/drawingml/2006/main">
+              <a:ext uri="{FF2B5EF4-FFF2-40B4-BE49-F238E27FC236}">
+                <a16:creationId xmlns:a16="http://schemas.microsoft.com/office/drawing/2014/main" id="{3072100C-FE12-47A1-A1CE-E3B97D6D25FF}"/>
+              </a:ext>
+            </a:extLst>
+          </p:cNvPr>
+          <p:cNvSpPr>
+            <a:spLocks xmlns:a="http://schemas.openxmlformats.org/drawingml/2006/main" noGrp="1"/>
+          </p:cNvSpPr>
+          <p:nvPr/>
+        </p:nvSpPr>
+        <p:spPr>
+          <a:xfrm xmlns:a="http://schemas.openxmlformats.org/drawingml/2006/main">
+            <a:off x="685800" y="323850"/>
+            <a:ext cx="10820400" cy="285750"/>
+          </a:xfrm>
+          <a:prstGeom xmlns:a="http://schemas.openxmlformats.org/drawingml/2006/main" prst="rect">
+            <a:avLst/>
+          </a:prstGeom>
+          <a:noFill xmlns:a="http://schemas.openxmlformats.org/drawingml/2006/main"/>
+          <a:ln xmlns:a="http://schemas.openxmlformats.org/drawingml/2006/main" w="0">
+            <a:noFill/>
+          </a:ln>
+        </p:spPr>
+        <p:txBody>
+          <a:bodyPr xmlns:a="http://schemas.openxmlformats.org/drawingml/2006/main" anchor="ctr">
+            <a:normAutofit fontScale="100000"/>
+          </a:bodyPr>
+          <a:lstStyle xmlns:a="http://schemas.openxmlformats.org/drawingml/2006/main"/>
+          <a:p xmlns:a="http://schemas.openxmlformats.org/drawingml/2006/main">
+            <a:pPr algn="ctr">
+              <a:defRPr sz="1125" b="1">
+                <a:solidFill>
+                  <a:srgbClr val="FF0080"/>
+                </a:solidFill>
+                <a:latin typeface="Calibri"/>
+                <a:ea typeface="Calibri"/>
+                <a:cs typeface="Calibri"/>
+              </a:defRPr>
+            </a:pPr>
+            <a:r>
+              <a:rPr sz="1125" b="1">
+                <a:solidFill>
+                  <a:srgbClr val="FF0080"/>
+                </a:solidFill>
+                <a:latin typeface="Calibri"/>
+                <a:ea typeface="Calibri"/>
+                <a:cs typeface="Calibri"/>
+              </a:rPr>
+              <a:t>OBSERVED RESULTS</a:t>
+            </a:r>
+          </a:p>
+        </p:txBody>
+      </p:sp>
+      <p:sp>
+        <p:nvSpPr>
+          <p:cNvPr id="2" name="">
+            <a:extLst xmlns:a="http://schemas.openxmlformats.org/drawingml/2006/main">
+              <a:ext uri="{FF2B5EF4-FFF2-40B4-BE49-F238E27FC236}">
+                <a16:creationId xmlns:a16="http://schemas.microsoft.com/office/drawing/2014/main" id="{8BC9CD74-D0D2-46F4-A263-3CA36B3913DE}"/>
+              </a:ext>
+            </a:extLst>
+          </p:cNvPr>
+          <p:cNvSpPr>
+            <a:spLocks xmlns:a="http://schemas.openxmlformats.org/drawingml/2006/main" noGrp="1"/>
+          </p:cNvSpPr>
+          <p:nvPr/>
+        </p:nvSpPr>
+        <p:spPr>
+          <a:xfrm xmlns:a="http://schemas.openxmlformats.org/drawingml/2006/main">
+            <a:off x="685800" y="628650"/>
+            <a:ext cx="10820400" cy="552450"/>
+          </a:xfrm>
+          <a:prstGeom xmlns:a="http://schemas.openxmlformats.org/drawingml/2006/main" prst="rect">
+            <a:avLst/>
+          </a:prstGeom>
+          <a:noFill xmlns:a="http://schemas.openxmlformats.org/drawingml/2006/main"/>
+          <a:ln xmlns:a="http://schemas.openxmlformats.org/drawingml/2006/main" w="0">
+            <a:noFill/>
+          </a:ln>
+        </p:spPr>
+        <p:txBody>
+          <a:bodyPr xmlns:a="http://schemas.openxmlformats.org/drawingml/2006/main" anchor="ctr">
+            <a:normAutofit fontScale="100000"/>
+          </a:bodyPr>
+          <a:lstStyle xmlns:a="http://schemas.openxmlformats.org/drawingml/2006/main"/>
+          <a:p xmlns:a="http://schemas.openxmlformats.org/drawingml/2006/main">
+            <a:pPr algn="ctr">
+              <a:defRPr sz="2175" b="1">
+                <a:solidFill>
+                  <a:srgbClr val="F0F4F8"/>
+                </a:solidFill>
+                <a:latin typeface="Calibri"/>
+                <a:ea typeface="Calibri"/>
+                <a:cs typeface="Calibri"/>
+              </a:defRPr>
+            </a:pPr>
+            <a:r>
+              <a:rPr sz="2175" b="1">
+                <a:solidFill>
+                  <a:srgbClr val="F0F4F8"/>
+                </a:solidFill>
+                <a:latin typeface="Calibri"/>
+                <a:ea typeface="Calibri"/>
+                <a:cs typeface="Calibri"/>
+              </a:rPr>
+              <a:t>観測された結果</a:t>
+            </a:r>
+          </a:p>
+        </p:txBody>
+      </p:sp>
+      <p:sp>
+        <p:nvSpPr>
+          <p:cNvPr id="3" name="">
+            <a:extLst xmlns:a="http://schemas.openxmlformats.org/drawingml/2006/main">
+              <a:ext uri="{FF2B5EF4-FFF2-40B4-BE49-F238E27FC236}">
+                <a16:creationId xmlns:a16="http://schemas.microsoft.com/office/drawing/2014/main" id="{5C6F8895-BB6B-4CC3-BF10-1F4C05C7177A}"/>
+              </a:ext>
+            </a:extLst>
+          </p:cNvPr>
+          <p:cNvSpPr>
+            <a:spLocks xmlns:a="http://schemas.openxmlformats.org/drawingml/2006/main" noGrp="1"/>
+          </p:cNvSpPr>
+          <p:nvPr/>
+        </p:nvSpPr>
+        <p:spPr>
+          <a:xfrm xmlns:a="http://schemas.openxmlformats.org/drawingml/2006/main">
+            <a:off x="742950" y="1257300"/>
+            <a:ext cx="10706100" cy="361950"/>
+          </a:xfrm>
+          <a:prstGeom xmlns:a="http://schemas.openxmlformats.org/drawingml/2006/main" prst="rect">
+            <a:avLst/>
+          </a:prstGeom>
+          <a:noFill xmlns:a="http://schemas.openxmlformats.org/drawingml/2006/main"/>
+          <a:ln xmlns:a="http://schemas.openxmlformats.org/drawingml/2006/main" w="0">
+            <a:noFill/>
+          </a:ln>
+        </p:spPr>
+        <p:txBody>
+          <a:bodyPr xmlns:a="http://schemas.openxmlformats.org/drawingml/2006/main" anchor="ctr">
+            <a:normAutofit fontScale="100000"/>
+          </a:bodyPr>
+          <a:lstStyle xmlns:a="http://schemas.openxmlformats.org/drawingml/2006/main"/>
+          <a:p xmlns:a="http://schemas.openxmlformats.org/drawingml/2006/main">
+            <a:pPr algn="ctr">
+              <a:defRPr sz="1425" b="1">
+                <a:solidFill>
+                  <a:srgbClr val="00E5FF"/>
+                </a:solidFill>
+                <a:latin typeface="Calibri"/>
+                <a:ea typeface="Calibri"/>
+                <a:cs typeface="Calibri"/>
+              </a:defRPr>
+            </a:pPr>
+            <a:r>
+              <a:rPr sz="1425" b="1">
+                <a:solidFill>
+                  <a:srgbClr val="00E5FF"/>
+                </a:solidFill>
+                <a:latin typeface="Calibri"/>
+                <a:ea typeface="Calibri"/>
+                <a:cs typeface="Calibri"/>
+              </a:rPr>
+              <a:t>E条件　強硬型×強硬型　国際法OFF　Hotline OFF</a:t>
+            </a:r>
+          </a:p>
+        </p:txBody>
+      </p:sp>
+      <p:sp>
+        <p:nvSpPr>
+          <p:cNvPr id="4" name="">
+            <a:extLst xmlns:a="http://schemas.openxmlformats.org/drawingml/2006/main">
+              <a:ext uri="{FF2B5EF4-FFF2-40B4-BE49-F238E27FC236}">
+                <a16:creationId xmlns:a16="http://schemas.microsoft.com/office/drawing/2014/main" id="{5C663BA4-13FE-430A-82E5-8742929F45EF}"/>
+              </a:ext>
+            </a:extLst>
+          </p:cNvPr>
+          <p:cNvSpPr>
+            <a:spLocks xmlns:a="http://schemas.openxmlformats.org/drawingml/2006/main" noGrp="1"/>
+          </p:cNvSpPr>
+          <p:nvPr/>
+        </p:nvSpPr>
+        <p:spPr>
+          <a:xfrm xmlns:a="http://schemas.openxmlformats.org/drawingml/2006/main">
+            <a:off x="904875" y="1809750"/>
+            <a:ext cx="2857500" cy="781050"/>
+          </a:xfrm>
+          <a:prstGeom xmlns:a="http://schemas.openxmlformats.org/drawingml/2006/main" prst="rect">
+            <a:avLst/>
+          </a:prstGeom>
+          <a:noFill xmlns:a="http://schemas.openxmlformats.org/drawingml/2006/main"/>
+          <a:ln xmlns:a="http://schemas.openxmlformats.org/drawingml/2006/main" w="0">
+            <a:noFill/>
+          </a:ln>
+        </p:spPr>
+        <p:txBody>
+          <a:bodyPr xmlns:a="http://schemas.openxmlformats.org/drawingml/2006/main" anchor="ctr">
+            <a:normAutofit fontScale="100000"/>
+          </a:bodyPr>
+          <a:lstStyle xmlns:a="http://schemas.openxmlformats.org/drawingml/2006/main"/>
+          <a:p xmlns:a="http://schemas.openxmlformats.org/drawingml/2006/main">
+            <a:pPr algn="ctr">
+              <a:defRPr sz="3450" b="1">
+                <a:solidFill>
+                  <a:srgbClr val="FF0080"/>
+                </a:solidFill>
+                <a:latin typeface="Calibri"/>
+                <a:ea typeface="Calibri"/>
+                <a:cs typeface="Calibri"/>
+              </a:defRPr>
+            </a:pPr>
+            <a:r>
+              <a:rPr sz="3450" b="1">
+                <a:solidFill>
+                  <a:srgbClr val="FF0080"/>
+                </a:solidFill>
+                <a:latin typeface="Calibri"/>
+                <a:ea typeface="Calibri"/>
+                <a:cs typeface="Calibri"/>
+              </a:rPr>
+              <a:t>87.5%</a:t>
+            </a:r>
+          </a:p>
+        </p:txBody>
+      </p:sp>
+      <p:sp>
+        <p:nvSpPr>
+          <p:cNvPr id="5" name="">
+            <a:extLst xmlns:a="http://schemas.openxmlformats.org/drawingml/2006/main">
+              <a:ext uri="{FF2B5EF4-FFF2-40B4-BE49-F238E27FC236}">
+                <a16:creationId xmlns:a16="http://schemas.microsoft.com/office/drawing/2014/main" id="{BF1D2F7C-DC21-4CBE-A3F9-660B81FEC298}"/>
+              </a:ext>
+            </a:extLst>
+          </p:cNvPr>
+          <p:cNvSpPr>
+            <a:spLocks xmlns:a="http://schemas.openxmlformats.org/drawingml/2006/main" noGrp="1"/>
+          </p:cNvSpPr>
+          <p:nvPr/>
+        </p:nvSpPr>
+        <p:spPr>
+          <a:xfrm xmlns:a="http://schemas.openxmlformats.org/drawingml/2006/main">
+            <a:off x="904875" y="2571750"/>
+            <a:ext cx="2857500" cy="304800"/>
+          </a:xfrm>
+          <a:prstGeom xmlns:a="http://schemas.openxmlformats.org/drawingml/2006/main" prst="rect">
+            <a:avLst/>
+          </a:prstGeom>
+          <a:noFill xmlns:a="http://schemas.openxmlformats.org/drawingml/2006/main"/>
+          <a:ln xmlns:a="http://schemas.openxmlformats.org/drawingml/2006/main" w="0">
+            <a:noFill/>
+          </a:ln>
+        </p:spPr>
+        <p:txBody>
+          <a:bodyPr xmlns:a="http://schemas.openxmlformats.org/drawingml/2006/main" anchor="ctr">
+            <a:normAutofit fontScale="100000"/>
+          </a:bodyPr>
+          <a:lstStyle xmlns:a="http://schemas.openxmlformats.org/drawingml/2006/main"/>
+          <a:p xmlns:a="http://schemas.openxmlformats.org/drawingml/2006/main">
+            <a:pPr algn="ctr">
+              <a:defRPr sz="1275" b="0">
+                <a:solidFill>
+                  <a:srgbClr val="AEBBCF"/>
+                </a:solidFill>
+                <a:latin typeface="Calibri"/>
+                <a:ea typeface="Calibri"/>
+                <a:cs typeface="Calibri"/>
+              </a:defRPr>
+            </a:pPr>
+            <a:r>
+              <a:rPr sz="1275" b="0">
+                <a:solidFill>
+                  <a:srgbClr val="AEBBCF"/>
+                </a:solidFill>
+                <a:latin typeface="Calibri"/>
+                <a:ea typeface="Calibri"/>
+                <a:cs typeface="Calibri"/>
+              </a:rPr>
+              <a:t>過剰反応率</a:t>
+            </a:r>
+          </a:p>
+        </p:txBody>
+      </p:sp>
+      <p:sp>
+        <p:nvSpPr>
+          <p:cNvPr id="6" name="">
+            <a:extLst xmlns:a="http://schemas.openxmlformats.org/drawingml/2006/main">
+              <a:ext uri="{FF2B5EF4-FFF2-40B4-BE49-F238E27FC236}">
+                <a16:creationId xmlns:a16="http://schemas.microsoft.com/office/drawing/2014/main" id="{7DE95877-BEAC-4724-8DC7-7190328BAA99}"/>
+              </a:ext>
+            </a:extLst>
+          </p:cNvPr>
+          <p:cNvSpPr>
+            <a:spLocks xmlns:a="http://schemas.openxmlformats.org/drawingml/2006/main" noGrp="1"/>
+          </p:cNvSpPr>
+          <p:nvPr/>
+        </p:nvSpPr>
+        <p:spPr>
+          <a:xfrm xmlns:a="http://schemas.openxmlformats.org/drawingml/2006/main">
+            <a:off x="4667250" y="1809750"/>
+            <a:ext cx="2857500" cy="781050"/>
+          </a:xfrm>
+          <a:prstGeom xmlns:a="http://schemas.openxmlformats.org/drawingml/2006/main" prst="rect">
+            <a:avLst/>
+          </a:prstGeom>
+          <a:noFill xmlns:a="http://schemas.openxmlformats.org/drawingml/2006/main"/>
+          <a:ln xmlns:a="http://schemas.openxmlformats.org/drawingml/2006/main" w="0">
+            <a:noFill/>
+          </a:ln>
+        </p:spPr>
+        <p:txBody>
+          <a:bodyPr xmlns:a="http://schemas.openxmlformats.org/drawingml/2006/main" anchor="ctr">
+            <a:normAutofit fontScale="100000"/>
+          </a:bodyPr>
+          <a:lstStyle xmlns:a="http://schemas.openxmlformats.org/drawingml/2006/main"/>
+          <a:p xmlns:a="http://schemas.openxmlformats.org/drawingml/2006/main">
+            <a:pPr algn="ctr">
+              <a:defRPr sz="3450" b="1">
+                <a:solidFill>
+                  <a:srgbClr val="00E5FF"/>
+                </a:solidFill>
+                <a:latin typeface="Calibri"/>
+                <a:ea typeface="Calibri"/>
+                <a:cs typeface="Calibri"/>
+              </a:defRPr>
+            </a:pPr>
+            <a:r>
+              <a:rPr sz="3450" b="1">
+                <a:solidFill>
+                  <a:srgbClr val="00E5FF"/>
+                </a:solidFill>
+                <a:latin typeface="Calibri"/>
+                <a:ea typeface="Calibri"/>
+                <a:cs typeface="Calibri"/>
+              </a:rPr>
+              <a:t>37.188</a:t>
+            </a:r>
+          </a:p>
+        </p:txBody>
+      </p:sp>
+      <p:sp>
+        <p:nvSpPr>
+          <p:cNvPr id="7" name="">
+            <a:extLst xmlns:a="http://schemas.openxmlformats.org/drawingml/2006/main">
+              <a:ext uri="{FF2B5EF4-FFF2-40B4-BE49-F238E27FC236}">
+                <a16:creationId xmlns:a16="http://schemas.microsoft.com/office/drawing/2014/main" id="{58DF8176-55B2-41E9-9BF9-55A98F8CC408}"/>
+              </a:ext>
+            </a:extLst>
+          </p:cNvPr>
+          <p:cNvSpPr>
+            <a:spLocks xmlns:a="http://schemas.openxmlformats.org/drawingml/2006/main" noGrp="1"/>
+          </p:cNvSpPr>
+          <p:nvPr/>
+        </p:nvSpPr>
+        <p:spPr>
+          <a:xfrm xmlns:a="http://schemas.openxmlformats.org/drawingml/2006/main">
+            <a:off x="4667250" y="2571750"/>
+            <a:ext cx="2857500" cy="304800"/>
+          </a:xfrm>
+          <a:prstGeom xmlns:a="http://schemas.openxmlformats.org/drawingml/2006/main" prst="rect">
+            <a:avLst/>
+          </a:prstGeom>
+          <a:noFill xmlns:a="http://schemas.openxmlformats.org/drawingml/2006/main"/>
+          <a:ln xmlns:a="http://schemas.openxmlformats.org/drawingml/2006/main" w="0">
+            <a:noFill/>
+          </a:ln>
+        </p:spPr>
+        <p:txBody>
+          <a:bodyPr xmlns:a="http://schemas.openxmlformats.org/drawingml/2006/main" anchor="ctr">
+            <a:normAutofit fontScale="100000"/>
+          </a:bodyPr>
+          <a:lstStyle xmlns:a="http://schemas.openxmlformats.org/drawingml/2006/main"/>
+          <a:p xmlns:a="http://schemas.openxmlformats.org/drawingml/2006/main">
+            <a:pPr algn="ctr">
+              <a:defRPr sz="1275" b="0">
+                <a:solidFill>
+                  <a:srgbClr val="AEBBCF"/>
+                </a:solidFill>
+                <a:latin typeface="Calibri"/>
+                <a:ea typeface="Calibri"/>
+                <a:cs typeface="Calibri"/>
+              </a:defRPr>
+            </a:pPr>
+            <a:r>
+              <a:rPr sz="1275" b="0">
+                <a:solidFill>
+                  <a:srgbClr val="AEBBCF"/>
+                </a:solidFill>
+                <a:latin typeface="Calibri"/>
+                <a:ea typeface="Calibri"/>
+                <a:cs typeface="Calibri"/>
+              </a:rPr>
+              <a:t>平均エスカレーション圧</a:t>
+            </a:r>
+          </a:p>
+        </p:txBody>
+      </p:sp>
+      <p:sp>
+        <p:nvSpPr>
+          <p:cNvPr id="8" name="">
+            <a:extLst xmlns:a="http://schemas.openxmlformats.org/drawingml/2006/main">
+              <a:ext uri="{FF2B5EF4-FFF2-40B4-BE49-F238E27FC236}">
+                <a16:creationId xmlns:a16="http://schemas.microsoft.com/office/drawing/2014/main" id="{F30D6F2D-0037-4B4A-9A11-92B7C4D330B6}"/>
+              </a:ext>
+            </a:extLst>
+          </p:cNvPr>
+          <p:cNvSpPr>
+            <a:spLocks xmlns:a="http://schemas.openxmlformats.org/drawingml/2006/main" noGrp="1"/>
+          </p:cNvSpPr>
+          <p:nvPr/>
+        </p:nvSpPr>
+        <p:spPr>
+          <a:xfrm xmlns:a="http://schemas.openxmlformats.org/drawingml/2006/main">
+            <a:off x="8429625" y="1809750"/>
+            <a:ext cx="2857500" cy="781050"/>
+          </a:xfrm>
+          <a:prstGeom xmlns:a="http://schemas.openxmlformats.org/drawingml/2006/main" prst="rect">
+            <a:avLst/>
+          </a:prstGeom>
+          <a:noFill xmlns:a="http://schemas.openxmlformats.org/drawingml/2006/main"/>
+          <a:ln xmlns:a="http://schemas.openxmlformats.org/drawingml/2006/main" w="0">
+            <a:noFill/>
+          </a:ln>
+        </p:spPr>
+        <p:txBody>
+          <a:bodyPr xmlns:a="http://schemas.openxmlformats.org/drawingml/2006/main" anchor="ctr">
+            <a:normAutofit fontScale="100000"/>
+          </a:bodyPr>
+          <a:lstStyle xmlns:a="http://schemas.openxmlformats.org/drawingml/2006/main"/>
+          <a:p xmlns:a="http://schemas.openxmlformats.org/drawingml/2006/main">
+            <a:pPr algn="ctr">
+              <a:defRPr sz="3450" b="1">
+                <a:solidFill>
+                  <a:srgbClr val="F0F4F8"/>
+                </a:solidFill>
+                <a:latin typeface="Calibri"/>
+                <a:ea typeface="Calibri"/>
+                <a:cs typeface="Calibri"/>
+              </a:defRPr>
+            </a:pPr>
+            <a:r>
+              <a:rPr sz="3450" b="1">
+                <a:solidFill>
+                  <a:srgbClr val="F0F4F8"/>
+                </a:solidFill>
+                <a:latin typeface="Calibri"/>
+                <a:ea typeface="Calibri"/>
+                <a:cs typeface="Calibri"/>
+              </a:rPr>
+              <a:t>68.375</a:t>
+            </a:r>
+          </a:p>
+        </p:txBody>
+      </p:sp>
+      <p:sp>
+        <p:nvSpPr>
+          <p:cNvPr id="9" name="">
+            <a:extLst xmlns:a="http://schemas.openxmlformats.org/drawingml/2006/main">
+              <a:ext uri="{FF2B5EF4-FFF2-40B4-BE49-F238E27FC236}">
+                <a16:creationId xmlns:a16="http://schemas.microsoft.com/office/drawing/2014/main" id="{DB2BE65F-C13D-43D6-B5E2-F731506C54E6}"/>
+              </a:ext>
+            </a:extLst>
+          </p:cNvPr>
+          <p:cNvSpPr>
+            <a:spLocks xmlns:a="http://schemas.openxmlformats.org/drawingml/2006/main" noGrp="1"/>
+          </p:cNvSpPr>
+          <p:nvPr/>
+        </p:nvSpPr>
+        <p:spPr>
+          <a:xfrm xmlns:a="http://schemas.openxmlformats.org/drawingml/2006/main">
+            <a:off x="8429625" y="2571750"/>
+            <a:ext cx="2857500" cy="304800"/>
+          </a:xfrm>
+          <a:prstGeom xmlns:a="http://schemas.openxmlformats.org/drawingml/2006/main" prst="rect">
+            <a:avLst/>
+          </a:prstGeom>
+          <a:noFill xmlns:a="http://schemas.openxmlformats.org/drawingml/2006/main"/>
+          <a:ln xmlns:a="http://schemas.openxmlformats.org/drawingml/2006/main" w="0">
+            <a:noFill/>
+          </a:ln>
+        </p:spPr>
+        <p:txBody>
+          <a:bodyPr xmlns:a="http://schemas.openxmlformats.org/drawingml/2006/main" anchor="ctr">
+            <a:normAutofit fontScale="100000"/>
+          </a:bodyPr>
+          <a:lstStyle xmlns:a="http://schemas.openxmlformats.org/drawingml/2006/main"/>
+          <a:p xmlns:a="http://schemas.openxmlformats.org/drawingml/2006/main">
+            <a:pPr algn="ctr">
+              <a:defRPr sz="1275" b="0">
+                <a:solidFill>
+                  <a:srgbClr val="AEBBCF"/>
+                </a:solidFill>
+                <a:latin typeface="Calibri"/>
+                <a:ea typeface="Calibri"/>
+                <a:cs typeface="Calibri"/>
+              </a:defRPr>
+            </a:pPr>
+            <a:r>
+              <a:rPr sz="1275" b="0">
+                <a:solidFill>
+                  <a:srgbClr val="AEBBCF"/>
+                </a:solidFill>
+                <a:latin typeface="Calibri"/>
+                <a:ea typeface="Calibri"/>
+                <a:cs typeface="Calibri"/>
+              </a:rPr>
+              <a:t>平均回復力</a:t>
+            </a:r>
+          </a:p>
+        </p:txBody>
+      </p:sp>
+      <p:sp>
+        <p:nvSpPr>
+          <p:cNvPr id="10" name="">
+            <a:extLst xmlns:a="http://schemas.openxmlformats.org/drawingml/2006/main">
+              <a:ext uri="{FF2B5EF4-FFF2-40B4-BE49-F238E27FC236}">
+                <a16:creationId xmlns:a16="http://schemas.microsoft.com/office/drawing/2014/main" id="{AADFC43C-147E-4A6C-BFC8-9338FC2E26EE}"/>
+              </a:ext>
+            </a:extLst>
+          </p:cNvPr>
+          <p:cNvSpPr>
+            <a:spLocks xmlns:a="http://schemas.openxmlformats.org/drawingml/2006/main" noGrp="1"/>
+          </p:cNvSpPr>
+          <p:nvPr/>
+        </p:nvSpPr>
+        <p:spPr>
+          <a:xfrm xmlns:a="http://schemas.openxmlformats.org/drawingml/2006/main">
+            <a:off x="1047750" y="3286125"/>
+            <a:ext cx="10096500" cy="838200"/>
+          </a:xfrm>
+          <a:prstGeom xmlns:a="http://schemas.openxmlformats.org/drawingml/2006/main" prst="rect">
+            <a:avLst/>
+          </a:prstGeom>
+          <a:noFill xmlns:a="http://schemas.openxmlformats.org/drawingml/2006/main"/>
+          <a:ln xmlns:a="http://schemas.openxmlformats.org/drawingml/2006/main" w="0">
+            <a:noFill/>
+          </a:ln>
+        </p:spPr>
+        <p:txBody>
+          <a:bodyPr xmlns:a="http://schemas.openxmlformats.org/drawingml/2006/main" anchor="ctr">
+            <a:normAutofit fontScale="100000"/>
+          </a:bodyPr>
+          <a:lstStyle xmlns:a="http://schemas.openxmlformats.org/drawingml/2006/main"/>
+          <a:p xmlns:a="http://schemas.openxmlformats.org/drawingml/2006/main">
+            <a:pPr algn="ctr">
+              <a:defRPr sz="1650" b="1">
+                <a:solidFill>
+                  <a:srgbClr val="F0F4F8"/>
+                </a:solidFill>
+                <a:latin typeface="Calibri"/>
+                <a:ea typeface="Calibri"/>
+                <a:cs typeface="Calibri"/>
+              </a:defRPr>
+            </a:pPr>
+            <a:r>
+              <a:rPr sz="1650" b="1">
+                <a:solidFill>
+                  <a:srgbClr val="F0F4F8"/>
+                </a:solidFill>
+                <a:latin typeface="Calibri"/>
+                <a:ea typeface="Calibri"/>
+                <a:cs typeface="Calibri"/>
+              </a:rPr>
+              <a:t>強硬型比較では、国際法・Hotlineがある条件で</a:t>
+            </a:r>
+          </a:p>
+          <a:p xmlns:a="http://schemas.openxmlformats.org/drawingml/2006/main">
+            <a:pPr algn="ctr">
+              <a:defRPr sz="1650" b="1">
+                <a:solidFill>
+                  <a:srgbClr val="F0F4F8"/>
+                </a:solidFill>
+                <a:latin typeface="Calibri"/>
+                <a:ea typeface="Calibri"/>
+                <a:cs typeface="Calibri"/>
+              </a:defRPr>
+            </a:pPr>
+            <a:r>
+              <a:rPr sz="1650" b="1">
+                <a:solidFill>
+                  <a:srgbClr val="F0F4F8"/>
+                </a:solidFill>
+                <a:latin typeface="Calibri"/>
+                <a:ea typeface="Calibri"/>
+                <a:cs typeface="Calibri"/>
+              </a:rPr>
+              <a:t>エスカレーション圧の低下と回復力の上昇が観測された</a:t>
+            </a:r>
+          </a:p>
+        </p:txBody>
+      </p:sp>
+      <p:sp>
+        <p:nvSpPr>
+          <p:cNvPr id="11" name="">
+            <a:extLst xmlns:a="http://schemas.openxmlformats.org/drawingml/2006/main">
+              <a:ext uri="{FF2B5EF4-FFF2-40B4-BE49-F238E27FC236}">
+                <a16:creationId xmlns:a16="http://schemas.microsoft.com/office/drawing/2014/main" id="{95B87C9C-3DE7-423C-9049-087313B598F7}"/>
+              </a:ext>
+            </a:extLst>
+          </p:cNvPr>
+          <p:cNvSpPr>
+            <a:spLocks xmlns:a="http://schemas.openxmlformats.org/drawingml/2006/main" noGrp="1"/>
+          </p:cNvSpPr>
+          <p:nvPr/>
+        </p:nvSpPr>
+        <p:spPr>
+          <a:xfrm xmlns:a="http://schemas.openxmlformats.org/drawingml/2006/main">
+            <a:off x="1000125" y="4524375"/>
+            <a:ext cx="4000500" cy="361950"/>
+          </a:xfrm>
+          <a:prstGeom xmlns:a="http://schemas.openxmlformats.org/drawingml/2006/main" prst="rect">
+            <a:avLst/>
+          </a:prstGeom>
+          <a:noFill xmlns:a="http://schemas.openxmlformats.org/drawingml/2006/main"/>
+          <a:ln xmlns:a="http://schemas.openxmlformats.org/drawingml/2006/main" w="0">
+            <a:noFill/>
+          </a:ln>
+        </p:spPr>
+        <p:txBody>
+          <a:bodyPr xmlns:a="http://schemas.openxmlformats.org/drawingml/2006/main" anchor="ctr">
+            <a:normAutofit fontScale="100000"/>
+          </a:bodyPr>
+          <a:lstStyle xmlns:a="http://schemas.openxmlformats.org/drawingml/2006/main"/>
+          <a:p xmlns:a="http://schemas.openxmlformats.org/drawingml/2006/main">
+            <a:pPr algn="l">
+              <a:defRPr sz="1350" b="1">
+                <a:solidFill>
+                  <a:srgbClr val="00E5FF"/>
+                </a:solidFill>
+                <a:latin typeface="Calibri"/>
+                <a:ea typeface="Calibri"/>
+                <a:cs typeface="Calibri"/>
+              </a:defRPr>
+            </a:pPr>
+            <a:r>
+              <a:rPr sz="1350" b="1">
+                <a:solidFill>
+                  <a:srgbClr val="00E5FF"/>
+                </a:solidFill>
+                <a:latin typeface="Calibri"/>
+                <a:ea typeface="Calibri"/>
+                <a:cs typeface="Calibri"/>
+              </a:rPr>
+              <a:t>慎重外交型でも過少反応を観測</a:t>
+            </a:r>
+          </a:p>
+        </p:txBody>
+      </p:sp>
+      <p:sp>
+        <p:nvSpPr>
+          <p:cNvPr id="12" name="">
+            <a:extLst xmlns:a="http://schemas.openxmlformats.org/drawingml/2006/main">
+              <a:ext uri="{FF2B5EF4-FFF2-40B4-BE49-F238E27FC236}">
+                <a16:creationId xmlns:a16="http://schemas.microsoft.com/office/drawing/2014/main" id="{1414352F-92E8-419E-A235-B6E9CD313D73}"/>
+              </a:ext>
+            </a:extLst>
+          </p:cNvPr>
+          <p:cNvSpPr>
+            <a:spLocks xmlns:a="http://schemas.openxmlformats.org/drawingml/2006/main" noGrp="1"/>
+          </p:cNvSpPr>
+          <p:nvPr/>
+        </p:nvSpPr>
+        <p:spPr>
+          <a:xfrm xmlns:a="http://schemas.openxmlformats.org/drawingml/2006/main">
+            <a:off x="1000125" y="4905375"/>
+            <a:ext cx="4000500" cy="495300"/>
+          </a:xfrm>
+          <a:prstGeom xmlns:a="http://schemas.openxmlformats.org/drawingml/2006/main" prst="rect">
+            <a:avLst/>
+          </a:prstGeom>
+          <a:noFill xmlns:a="http://schemas.openxmlformats.org/drawingml/2006/main"/>
+          <a:ln xmlns:a="http://schemas.openxmlformats.org/drawingml/2006/main" w="0">
+            <a:noFill/>
+          </a:ln>
+        </p:spPr>
+        <p:txBody>
+          <a:bodyPr xmlns:a="http://schemas.openxmlformats.org/drawingml/2006/main" anchor="ctr">
+            <a:normAutofit fontScale="100000"/>
+          </a:bodyPr>
+          <a:lstStyle xmlns:a="http://schemas.openxmlformats.org/drawingml/2006/main"/>
+          <a:p xmlns:a="http://schemas.openxmlformats.org/drawingml/2006/main">
+            <a:pPr algn="l">
+              <a:defRPr sz="1875" b="1">
+                <a:solidFill>
+                  <a:srgbClr val="F0F4F8"/>
+                </a:solidFill>
+                <a:latin typeface="Calibri"/>
+                <a:ea typeface="Calibri"/>
+                <a:cs typeface="Calibri"/>
+              </a:defRPr>
+            </a:pPr>
+            <a:r>
+              <a:rPr sz="1875" b="1">
+                <a:solidFill>
+                  <a:srgbClr val="F0F4F8"/>
+                </a:solidFill>
+                <a:latin typeface="Calibri"/>
+                <a:ea typeface="Calibri"/>
+                <a:cs typeface="Calibri"/>
+              </a:rPr>
+              <a:t>D条件　16.667%</a:t>
+            </a:r>
+          </a:p>
+        </p:txBody>
+      </p:sp>
+      <p:sp>
+        <p:nvSpPr>
+          <p:cNvPr id="13" name="">
+            <a:extLst xmlns:a="http://schemas.openxmlformats.org/drawingml/2006/main">
+              <a:ext uri="{FF2B5EF4-FFF2-40B4-BE49-F238E27FC236}">
+                <a16:creationId xmlns:a16="http://schemas.microsoft.com/office/drawing/2014/main" id="{A061CF89-F072-4C84-8564-D3C67B9FDBAD}"/>
+              </a:ext>
+            </a:extLst>
+          </p:cNvPr>
+          <p:cNvSpPr>
+            <a:spLocks xmlns:a="http://schemas.openxmlformats.org/drawingml/2006/main" noGrp="1"/>
+          </p:cNvSpPr>
+          <p:nvPr/>
+        </p:nvSpPr>
+        <p:spPr>
+          <a:xfrm xmlns:a="http://schemas.openxmlformats.org/drawingml/2006/main">
+            <a:off x="1000125" y="5410200"/>
+            <a:ext cx="4000500" cy="495300"/>
+          </a:xfrm>
+          <a:prstGeom xmlns:a="http://schemas.openxmlformats.org/drawingml/2006/main" prst="rect">
+            <a:avLst/>
+          </a:prstGeom>
+          <a:noFill xmlns:a="http://schemas.openxmlformats.org/drawingml/2006/main"/>
+          <a:ln xmlns:a="http://schemas.openxmlformats.org/drawingml/2006/main" w="0">
+            <a:noFill/>
+          </a:ln>
+        </p:spPr>
+        <p:txBody>
+          <a:bodyPr xmlns:a="http://schemas.openxmlformats.org/drawingml/2006/main" anchor="ctr">
+            <a:normAutofit fontScale="100000"/>
+          </a:bodyPr>
+          <a:lstStyle xmlns:a="http://schemas.openxmlformats.org/drawingml/2006/main"/>
+          <a:p xmlns:a="http://schemas.openxmlformats.org/drawingml/2006/main">
+            <a:pPr algn="l">
+              <a:defRPr sz="1875" b="1">
+                <a:solidFill>
+                  <a:srgbClr val="F0F4F8"/>
+                </a:solidFill>
+                <a:latin typeface="Calibri"/>
+                <a:ea typeface="Calibri"/>
+                <a:cs typeface="Calibri"/>
+              </a:defRPr>
+            </a:pPr>
+            <a:r>
+              <a:rPr sz="1875" b="1">
+                <a:solidFill>
+                  <a:srgbClr val="F0F4F8"/>
+                </a:solidFill>
+                <a:latin typeface="Calibri"/>
+                <a:ea typeface="Calibri"/>
+                <a:cs typeface="Calibri"/>
+              </a:rPr>
+              <a:t>H条件　12.5%</a:t>
+            </a:r>
+          </a:p>
+        </p:txBody>
+      </p:sp>
+      <p:sp>
+        <p:nvSpPr>
+          <p:cNvPr id="14" name="">
+            <a:extLst xmlns:a="http://schemas.openxmlformats.org/drawingml/2006/main">
+              <a:ext uri="{FF2B5EF4-FFF2-40B4-BE49-F238E27FC236}">
+                <a16:creationId xmlns:a16="http://schemas.microsoft.com/office/drawing/2014/main" id="{122768C9-BBF6-4196-B598-7CA77BB41723}"/>
+              </a:ext>
+            </a:extLst>
+          </p:cNvPr>
+          <p:cNvSpPr>
+            <a:spLocks xmlns:a="http://schemas.openxmlformats.org/drawingml/2006/main" noGrp="1"/>
+          </p:cNvSpPr>
+          <p:nvPr/>
+        </p:nvSpPr>
+        <p:spPr>
+          <a:xfrm xmlns:a="http://schemas.openxmlformats.org/drawingml/2006/main">
+            <a:off x="5905500" y="4695825"/>
+            <a:ext cx="5000625" cy="1000125"/>
+          </a:xfrm>
+          <a:prstGeom xmlns:a="http://schemas.openxmlformats.org/drawingml/2006/main" prst="rect">
+            <a:avLst/>
+          </a:prstGeom>
+          <a:noFill xmlns:a="http://schemas.openxmlformats.org/drawingml/2006/main"/>
+          <a:ln xmlns:a="http://schemas.openxmlformats.org/drawingml/2006/main" w="0">
+            <a:noFill/>
+          </a:ln>
+        </p:spPr>
+        <p:txBody>
+          <a:bodyPr xmlns:a="http://schemas.openxmlformats.org/drawingml/2006/main" anchor="ctr">
+            <a:normAutofit fontScale="100000"/>
+          </a:bodyPr>
+          <a:lstStyle xmlns:a="http://schemas.openxmlformats.org/drawingml/2006/main"/>
+          <a:p xmlns:a="http://schemas.openxmlformats.org/drawingml/2006/main">
+            <a:pPr algn="ctr">
+              <a:defRPr sz="1875" b="1">
+                <a:solidFill>
+                  <a:srgbClr val="FF0080"/>
+                </a:solidFill>
+                <a:latin typeface="Calibri"/>
+                <a:ea typeface="Calibri"/>
+                <a:cs typeface="Calibri"/>
+              </a:defRPr>
+            </a:pPr>
+            <a:r>
+              <a:rPr sz="1875" b="1">
+                <a:solidFill>
+                  <a:srgbClr val="FF0080"/>
+                </a:solidFill>
+                <a:latin typeface="Calibri"/>
+                <a:ea typeface="Calibri"/>
+                <a:cs typeface="Calibri"/>
+              </a:rPr>
+              <a:t>因果関係ではなく、</a:t>
+            </a:r>
+          </a:p>
+          <a:p xmlns:a="http://schemas.openxmlformats.org/drawingml/2006/main">
+            <a:pPr algn="ctr">
+              <a:defRPr sz="1875" b="1">
+                <a:solidFill>
+                  <a:srgbClr val="FF0080"/>
+                </a:solidFill>
+                <a:latin typeface="Calibri"/>
+                <a:ea typeface="Calibri"/>
+                <a:cs typeface="Calibri"/>
+              </a:defRPr>
+            </a:pPr>
+            <a:r>
+              <a:rPr sz="1875" b="1">
+                <a:solidFill>
+                  <a:srgbClr val="FF0080"/>
+                </a:solidFill>
+                <a:latin typeface="Calibri"/>
+                <a:ea typeface="Calibri"/>
+                <a:cs typeface="Calibri"/>
+              </a:rPr>
+              <a:t>この36runで観測された関連</a:t>
+            </a:r>
+          </a:p>
+        </p:txBody>
+      </p:sp>
+    </p:spTree>
+    <p:extLst>
+      <p:ext uri="{BB962C8B-B14F-4D97-AF65-F5344CB8AC3E}">
+        <p14:creationId xmlns:p14="http://schemas.microsoft.com/office/powerpoint/2010/main" val="2033197565"/>
+      </p:ext>
+    </p:extLst>
+  </p:cSld>
+</p:sld>
+</file>
+
+<file path=ppt/slides/slide6.xml><?xml version="1.0" encoding="utf-8"?>
+<p:sld xmlns:p="http://schemas.openxmlformats.org/presentationml/2006/main">
+  <p:cSld>
+    <p:bg>
+      <p:bgPr>
+        <a:solidFill xmlns:a="http://schemas.openxmlformats.org/drawingml/2006/main">
+          <a:srgbClr val="0A0F1E"/>
+        </a:solidFill>
+      </p:bgPr>
+    </p:bg>
+    <p:spTree>
+      <p:nvGrpSpPr>
+        <p:cNvPr id="1" name=""/>
+        <p:cNvGrpSpPr/>
+        <p:nvPr/>
+      </p:nvGrpSpPr>
+      <p:grpSpPr>
+        <a:xfrm xmlns:a="http://schemas.openxmlformats.org/drawingml/2006/main"/>
+      </p:grpSpPr>
+      <p:sp>
+        <p:nvSpPr>
+          <p:cNvPr id="8" name="">
+            <a:extLst xmlns:a="http://schemas.openxmlformats.org/drawingml/2006/main">
+              <a:ext uri="{FF2B5EF4-FFF2-40B4-BE49-F238E27FC236}">
+                <a16:creationId xmlns:a16="http://schemas.microsoft.com/office/drawing/2014/main" id="{1D8FA86B-A395-41DB-9F74-7726DBFF439B}"/>
+              </a:ext>
+            </a:extLst>
+          </p:cNvPr>
+          <p:cNvSpPr>
+            <a:spLocks xmlns:a="http://schemas.openxmlformats.org/drawingml/2006/main" noGrp="1"/>
+          </p:cNvSpPr>
+          <p:nvPr/>
+        </p:nvSpPr>
+        <p:spPr>
+          <a:xfrm xmlns:a="http://schemas.openxmlformats.org/drawingml/2006/main">
+            <a:off x="685800" y="323850"/>
+            <a:ext cx="10820400" cy="285750"/>
+          </a:xfrm>
+          <a:prstGeom xmlns:a="http://schemas.openxmlformats.org/drawingml/2006/main" prst="rect">
+            <a:avLst/>
+          </a:prstGeom>
+          <a:noFill xmlns:a="http://schemas.openxmlformats.org/drawingml/2006/main"/>
+          <a:ln xmlns:a="http://schemas.openxmlformats.org/drawingml/2006/main" w="0">
+            <a:noFill/>
+          </a:ln>
+        </p:spPr>
+        <p:txBody>
+          <a:bodyPr xmlns:a="http://schemas.openxmlformats.org/drawingml/2006/main" anchor="ctr">
+            <a:normAutofit fontScale="100000"/>
+          </a:bodyPr>
+          <a:lstStyle xmlns:a="http://schemas.openxmlformats.org/drawingml/2006/main"/>
+          <a:p xmlns:a="http://schemas.openxmlformats.org/drawingml/2006/main">
+            <a:pPr algn="ctr">
+              <a:defRPr sz="1125" b="1">
+                <a:solidFill>
+                  <a:srgbClr val="00E5FF"/>
+                </a:solidFill>
+                <a:latin typeface="Calibri"/>
+                <a:ea typeface="Calibri"/>
+                <a:cs typeface="Calibri"/>
+              </a:defRPr>
+            </a:pPr>
+            <a:r>
+              <a:rPr sz="1125" b="1">
+                <a:solidFill>
+                  <a:srgbClr val="00E5FF"/>
+                </a:solidFill>
+                <a:latin typeface="Calibri"/>
+                <a:ea typeface="Calibri"/>
+                <a:cs typeface="Calibri"/>
+              </a:rPr>
+              <a:t>RESEARCH INTERPRETATION</a:t>
+            </a:r>
+          </a:p>
+        </p:txBody>
+      </p:sp>
+      <p:sp>
+        <p:nvSpPr>
+          <p:cNvPr id="2" name="">
+            <a:extLst xmlns:a="http://schemas.openxmlformats.org/drawingml/2006/main">
+              <a:ext uri="{FF2B5EF4-FFF2-40B4-BE49-F238E27FC236}">
+                <a16:creationId xmlns:a16="http://schemas.microsoft.com/office/drawing/2014/main" id="{28CEECF1-71ED-4925-A65A-DD24AC4E7B87}"/>
+              </a:ext>
+            </a:extLst>
+          </p:cNvPr>
+          <p:cNvSpPr>
+            <a:spLocks xmlns:a="http://schemas.openxmlformats.org/drawingml/2006/main" noGrp="1"/>
+          </p:cNvSpPr>
+          <p:nvPr/>
+        </p:nvSpPr>
+        <p:spPr>
+          <a:xfrm xmlns:a="http://schemas.openxmlformats.org/drawingml/2006/main">
+            <a:off x="685800" y="628650"/>
+            <a:ext cx="10820400" cy="552450"/>
+          </a:xfrm>
+          <a:prstGeom xmlns:a="http://schemas.openxmlformats.org/drawingml/2006/main" prst="rect">
+            <a:avLst/>
+          </a:prstGeom>
+          <a:noFill xmlns:a="http://schemas.openxmlformats.org/drawingml/2006/main"/>
+          <a:ln xmlns:a="http://schemas.openxmlformats.org/drawingml/2006/main" w="0">
+            <a:noFill/>
+          </a:ln>
+        </p:spPr>
+        <p:txBody>
+          <a:bodyPr xmlns:a="http://schemas.openxmlformats.org/drawingml/2006/main" anchor="ctr">
+            <a:normAutofit fontScale="100000"/>
+          </a:bodyPr>
+          <a:lstStyle xmlns:a="http://schemas.openxmlformats.org/drawingml/2006/main"/>
+          <a:p xmlns:a="http://schemas.openxmlformats.org/drawingml/2006/main">
+            <a:pPr algn="ctr">
+              <a:defRPr sz="2175" b="1">
+                <a:solidFill>
+                  <a:srgbClr val="F0F4F8"/>
+                </a:solidFill>
+                <a:latin typeface="Calibri"/>
+                <a:ea typeface="Calibri"/>
+                <a:cs typeface="Calibri"/>
+              </a:defRPr>
+            </a:pPr>
+            <a:r>
+              <a:rPr sz="2175" b="1">
+                <a:solidFill>
+                  <a:srgbClr val="F0F4F8"/>
+                </a:solidFill>
+                <a:latin typeface="Calibri"/>
+                <a:ea typeface="Calibri"/>
+                <a:cs typeface="Calibri"/>
+              </a:rPr>
+              <a:t>研究としての読み方</a:t>
+            </a:r>
+          </a:p>
+        </p:txBody>
+      </p:sp>
+      <p:sp>
+        <p:nvSpPr>
+          <p:cNvPr id="3" name="">
+            <a:extLst xmlns:a="http://schemas.openxmlformats.org/drawingml/2006/main">
+              <a:ext uri="{FF2B5EF4-FFF2-40B4-BE49-F238E27FC236}">
+                <a16:creationId xmlns:a16="http://schemas.microsoft.com/office/drawing/2014/main" id="{E3C057F3-B237-4FBE-8065-6D8D16814747}"/>
+              </a:ext>
+            </a:extLst>
+          </p:cNvPr>
+          <p:cNvSpPr>
+            <a:spLocks xmlns:a="http://schemas.openxmlformats.org/drawingml/2006/main" noGrp="1"/>
+          </p:cNvSpPr>
+          <p:nvPr/>
+        </p:nvSpPr>
+        <p:spPr>
+          <a:xfrm xmlns:a="http://schemas.openxmlformats.org/drawingml/2006/main">
+            <a:off x="857250" y="1333500"/>
+            <a:ext cx="10477500" cy="523875"/>
+          </a:xfrm>
+          <a:prstGeom xmlns:a="http://schemas.openxmlformats.org/drawingml/2006/main" prst="rect">
+            <a:avLst/>
+          </a:prstGeom>
+          <a:noFill xmlns:a="http://schemas.openxmlformats.org/drawingml/2006/main"/>
+          <a:ln xmlns:a="http://schemas.openxmlformats.org/drawingml/2006/main" w="0">
+            <a:noFill/>
+          </a:ln>
+        </p:spPr>
+        <p:txBody>
+          <a:bodyPr xmlns:a="http://schemas.openxmlformats.org/drawingml/2006/main" anchor="ctr">
+            <a:normAutofit fontScale="100000"/>
+          </a:bodyPr>
+          <a:lstStyle xmlns:a="http://schemas.openxmlformats.org/drawingml/2006/main"/>
+          <a:p xmlns:a="http://schemas.openxmlformats.org/drawingml/2006/main">
+            <a:pPr algn="ctr">
+              <a:defRPr sz="1800" b="1">
+                <a:solidFill>
+                  <a:srgbClr val="F0F4F8"/>
+                </a:solidFill>
+                <a:latin typeface="Calibri"/>
+                <a:ea typeface="Calibri"/>
+                <a:cs typeface="Calibri"/>
+              </a:defRPr>
+            </a:pPr>
+            <a:r>
+              <a:rPr sz="1800" b="1">
+                <a:solidFill>
+                  <a:srgbClr val="F0F4F8"/>
+                </a:solidFill>
+                <a:latin typeface="Calibri"/>
+                <a:ea typeface="Calibri"/>
+                <a:cs typeface="Calibri"/>
+              </a:rPr>
+              <a:t>脅威に対して反応が強すぎても弱すぎても、恒常性を損なう</a:t>
+            </a:r>
+          </a:p>
+        </p:txBody>
+      </p:sp>
+      <p:sp>
+        <p:nvSpPr>
+          <p:cNvPr id="4" name="">
+            <a:extLst xmlns:a="http://schemas.openxmlformats.org/drawingml/2006/main">
+              <a:ext uri="{FF2B5EF4-FFF2-40B4-BE49-F238E27FC236}">
+                <a16:creationId xmlns:a16="http://schemas.microsoft.com/office/drawing/2014/main" id="{6E7199A0-98A8-410B-96D8-BFD112668A8F}"/>
+              </a:ext>
+            </a:extLst>
+          </p:cNvPr>
+          <p:cNvSpPr>
+            <a:spLocks xmlns:a="http://schemas.openxmlformats.org/drawingml/2006/main" noGrp="1"/>
+          </p:cNvSpPr>
+          <p:nvPr/>
+        </p:nvSpPr>
+        <p:spPr>
+          <a:xfrm xmlns:a="http://schemas.openxmlformats.org/drawingml/2006/main">
+            <a:off x="1047750" y="2143125"/>
+            <a:ext cx="10096500" cy="495300"/>
+          </a:xfrm>
+          <a:prstGeom xmlns:a="http://schemas.openxmlformats.org/drawingml/2006/main" prst="rect">
+            <a:avLst/>
+          </a:prstGeom>
+          <a:noFill xmlns:a="http://schemas.openxmlformats.org/drawingml/2006/main"/>
+          <a:ln xmlns:a="http://schemas.openxmlformats.org/drawingml/2006/main" w="0">
+            <a:noFill/>
+          </a:ln>
+        </p:spPr>
+        <p:txBody>
+          <a:bodyPr xmlns:a="http://schemas.openxmlformats.org/drawingml/2006/main" anchor="ctr">
+            <a:normAutofit fontScale="100000"/>
+          </a:bodyPr>
+          <a:lstStyle xmlns:a="http://schemas.openxmlformats.org/drawingml/2006/main"/>
+          <a:p xmlns:a="http://schemas.openxmlformats.org/drawingml/2006/main">
+            <a:pPr algn="ctr">
+              <a:defRPr sz="1575" b="1">
+                <a:solidFill>
+                  <a:srgbClr val="00E5FF"/>
+                </a:solidFill>
+                <a:latin typeface="Calibri"/>
+                <a:ea typeface="Calibri"/>
+                <a:cs typeface="Calibri"/>
+              </a:defRPr>
+            </a:pPr>
+            <a:r>
+              <a:rPr sz="1575" b="1">
+                <a:solidFill>
+                  <a:srgbClr val="00E5FF"/>
+                </a:solidFill>
+                <a:latin typeface="Calibri"/>
+                <a:ea typeface="Calibri"/>
+                <a:cs typeface="Calibri"/>
+              </a:rPr>
+              <a:t>国際法やHotlineが、エスカレーション抑制と回復力に関連した可能性</a:t>
+            </a:r>
+          </a:p>
+        </p:txBody>
+      </p:sp>
+      <p:sp>
+        <p:nvSpPr>
+          <p:cNvPr id="5" name="">
+            <a:extLst xmlns:a="http://schemas.openxmlformats.org/drawingml/2006/main">
+              <a:ext uri="{FF2B5EF4-FFF2-40B4-BE49-F238E27FC236}">
+                <a16:creationId xmlns:a16="http://schemas.microsoft.com/office/drawing/2014/main" id="{575CBABB-83D4-4E7E-AE27-84D6E4A6B820}"/>
+              </a:ext>
+            </a:extLst>
+          </p:cNvPr>
+          <p:cNvSpPr>
+            <a:spLocks xmlns:a="http://schemas.openxmlformats.org/drawingml/2006/main" noGrp="1"/>
+          </p:cNvSpPr>
+          <p:nvPr/>
+        </p:nvSpPr>
+        <p:spPr>
+          <a:xfrm xmlns:a="http://schemas.openxmlformats.org/drawingml/2006/main">
+            <a:off x="1047750" y="2809875"/>
+            <a:ext cx="10096500" cy="419100"/>
+          </a:xfrm>
+          <a:prstGeom xmlns:a="http://schemas.openxmlformats.org/drawingml/2006/main" prst="rect">
+            <a:avLst/>
+          </a:prstGeom>
+          <a:noFill xmlns:a="http://schemas.openxmlformats.org/drawingml/2006/main"/>
+          <a:ln xmlns:a="http://schemas.openxmlformats.org/drawingml/2006/main" w="0">
+            <a:noFill/>
+          </a:ln>
+        </p:spPr>
+        <p:txBody>
+          <a:bodyPr xmlns:a="http://schemas.openxmlformats.org/drawingml/2006/main" anchor="ctr">
+            <a:normAutofit fontScale="100000"/>
+          </a:bodyPr>
+          <a:lstStyle xmlns:a="http://schemas.openxmlformats.org/drawingml/2006/main"/>
+          <a:p xmlns:a="http://schemas.openxmlformats.org/drawingml/2006/main">
+            <a:pPr algn="ctr">
+              <a:defRPr sz="1575" b="1">
+                <a:solidFill>
+                  <a:srgbClr val="FF0080"/>
+                </a:solidFill>
+                <a:latin typeface="Calibri"/>
+                <a:ea typeface="Calibri"/>
+                <a:cs typeface="Calibri"/>
+              </a:defRPr>
+            </a:pPr>
+            <a:r>
+              <a:rPr sz="1575" b="1">
+                <a:solidFill>
+                  <a:srgbClr val="FF0080"/>
+                </a:solidFill>
+                <a:latin typeface="Calibri"/>
+                <a:ea typeface="Calibri"/>
+                <a:cs typeface="Calibri"/>
+              </a:rPr>
+              <a:t>慎重さも常に適応的とは限らない</a:t>
+            </a:r>
+          </a:p>
+        </p:txBody>
+      </p:sp>
+      <p:graphicFrame>
+        <p:nvGraphicFramePr>
+          <p:cNvPr id="13" name=""/>
+          <p:cNvGraphicFramePr/>
+          <p:nvPr/>
+        </p:nvGraphicFramePr>
+        <p:xfrm>
+          <a:off xmlns:a="http://schemas.openxmlformats.org/drawingml/2006/main" x="1428750" y="3619500"/>
+          <a:ext xmlns:a="http://schemas.openxmlformats.org/drawingml/2006/main" cx="9334500" cy="1428750"/>
+        </p:xfrm>
+        <a:graphic xmlns:a="http://schemas.openxmlformats.org/drawingml/2006/main">
+          <a:graphicData uri="http://schemas.openxmlformats.org/drawingml/2006/table">
+            <a:tbl>
+              <a:tblPr/>
+              <a:tblGrid>
+                <a:gridCol w="4667250"/>
+                <a:gridCol w="4667250"/>
+              </a:tblGrid>
+              <a:tr h="476250">
+                <a:tc>
+                  <a:txBody>
+                    <a:bodyPr/>
+                    <a:lstStyle/>
+                    <a:p>
+                      <a:r>
+                        <a:rPr sz="1275" b="1">
+                          <a:solidFill>
+                            <a:srgbClr val="00E5FF"/>
+                          </a:solidFill>
+                          <a:latin typeface="Calibri"/>
+                          <a:ea typeface="Calibri"/>
+                          <a:cs typeface="Calibri"/>
+                        </a:rPr>
+                        <a:t>run構成</a:t>
+                      </a:r>
+                    </a:p>
+                  </a:txBody>
+                  <a:tcPr marL="91440" marR="91440" marT="45720" marB="45720" anchor="ctr">
+                    <a:solidFill>
+                      <a:srgbClr val="123047"/>
+                    </a:solidFill>
+                  </a:tcPr>
+                </a:tc>
+                <a:tc>
+                  <a:txBody>
+                    <a:bodyPr/>
+                    <a:lstStyle/>
+                    <a:p>
+                      <a:r>
+                        <a:rPr sz="1275">
+                          <a:solidFill>
+                            <a:srgbClr val="F0F4F8"/>
+                          </a:solidFill>
+                          <a:latin typeface="Calibri"/>
+                          <a:ea typeface="Calibri"/>
+                          <a:cs typeface="Calibri"/>
+                        </a:rPr>
+                        <a:t>全36run。条件ごとに2〜5runで不均等</a:t>
+                      </a:r>
+                    </a:p>
+                  </a:txBody>
+                  <a:tcPr marL="91440" marR="91440" marT="45720" marB="45720" anchor="ctr">
+                    <a:solidFill>
+                      <a:srgbClr val="0D1728"/>
+                    </a:solidFill>
+                  </a:tcPr>
+                </a:tc>
+              </a:tr>
+              <a:tr h="476250">
+                <a:tc>
+                  <a:txBody>
+                    <a:bodyPr/>
+                    <a:lstStyle/>
+                    <a:p>
+                      <a:r>
+                        <a:rPr sz="1275" b="1">
+                          <a:solidFill>
+                            <a:srgbClr val="00E5FF"/>
+                          </a:solidFill>
+                          <a:latin typeface="Calibri"/>
+                          <a:ea typeface="Calibri"/>
+                          <a:cs typeface="Calibri"/>
+                        </a:rPr>
+                        <a:t>seed記録</a:t>
+                      </a:r>
+                    </a:p>
+                  </a:txBody>
+                  <a:tcPr marL="91440" marR="91440" marT="45720" marB="45720" anchor="ctr">
+                    <a:solidFill>
+                      <a:srgbClr val="123047"/>
+                    </a:solidFill>
+                  </a:tcPr>
+                </a:tc>
+                <a:tc>
+                  <a:txBody>
+                    <a:bodyPr/>
+                    <a:lstStyle/>
+                    <a:p>
+                      <a:r>
+                        <a:rPr sz="1275">
+                          <a:solidFill>
+                            <a:srgbClr val="F0F4F8"/>
+                          </a:solidFill>
+                          <a:latin typeface="Calibri"/>
+                          <a:ea typeface="Calibri"/>
+                          <a:cs typeface="Calibri"/>
+                        </a:rPr>
+                        <a:t>26/36run</a:t>
+                      </a:r>
+                    </a:p>
+                  </a:txBody>
+                  <a:tcPr marL="91440" marR="91440" marT="45720" marB="45720" anchor="ctr">
+                    <a:solidFill>
+                      <a:srgbClr val="0D1728"/>
+                    </a:solidFill>
+                  </a:tcPr>
+                </a:tc>
+              </a:tr>
+              <a:tr h="476250">
+                <a:tc>
+                  <a:txBody>
+                    <a:bodyPr/>
+                    <a:lstStyle/>
+                    <a:p>
+                      <a:r>
+                        <a:rPr sz="1275" b="1">
+                          <a:solidFill>
+                            <a:srgbClr val="00E5FF"/>
+                          </a:solidFill>
+                          <a:latin typeface="Calibri"/>
+                          <a:ea typeface="Calibri"/>
+                          <a:cs typeface="Calibri"/>
+                        </a:rPr>
+                        <a:t>結論の範囲</a:t>
+                      </a:r>
+                    </a:p>
+                  </a:txBody>
+                  <a:tcPr marL="91440" marR="91440" marT="45720" marB="45720" anchor="ctr">
+                    <a:solidFill>
+                      <a:srgbClr val="123047"/>
+                    </a:solidFill>
+                  </a:tcPr>
+                </a:tc>
+                <a:tc>
+                  <a:txBody>
+                    <a:bodyPr/>
+                    <a:lstStyle/>
+                    <a:p>
+                      <a:r>
+                        <a:rPr sz="1275">
+                          <a:solidFill>
+                            <a:srgbClr val="F0F4F8"/>
+                          </a:solidFill>
+                          <a:latin typeface="Calibri"/>
+                          <a:ea typeface="Calibri"/>
+                          <a:cs typeface="Calibri"/>
+                        </a:rPr>
+                        <a:t>探索的観測。一般性や因果関係を断定できない</a:t>
+                      </a:r>
+                    </a:p>
+                  </a:txBody>
+                  <a:tcPr marL="91440" marR="91440" marT="45720" marB="45720" anchor="ctr">
+                    <a:solidFill>
+                      <a:srgbClr val="0D1728"/>
+                    </a:solidFill>
+                  </a:tcPr>
+                </a:tc>
+              </a:tr>
+            </a:tbl>
+          </a:graphicData>
+        </a:graphic>
+      </p:graphicFrame>
+      <p:sp>
+        <p:nvSpPr>
+          <p:cNvPr id="7" name="">
+            <a:extLst xmlns:a="http://schemas.openxmlformats.org/drawingml/2006/main">
+              <a:ext uri="{FF2B5EF4-FFF2-40B4-BE49-F238E27FC236}">
+                <a16:creationId xmlns:a16="http://schemas.microsoft.com/office/drawing/2014/main" id="{94DD9B27-7E4A-40F1-B9BA-ACED1A3E1F27}"/>
+              </a:ext>
+            </a:extLst>
+          </p:cNvPr>
+          <p:cNvSpPr>
+            <a:spLocks xmlns:a="http://schemas.openxmlformats.org/drawingml/2006/main" noGrp="1"/>
+          </p:cNvSpPr>
+          <p:nvPr/>
+        </p:nvSpPr>
+        <p:spPr>
+          <a:xfrm xmlns:a="http://schemas.openxmlformats.org/drawingml/2006/main">
+            <a:off x="857250" y="5476875"/>
+            <a:ext cx="10477500" cy="476250"/>
+          </a:xfrm>
+          <a:prstGeom xmlns:a="http://schemas.openxmlformats.org/drawingml/2006/main" prst="rect">
+            <a:avLst/>
+          </a:prstGeom>
+          <a:noFill xmlns:a="http://schemas.openxmlformats.org/drawingml/2006/main"/>
+          <a:ln xmlns:a="http://schemas.openxmlformats.org/drawingml/2006/main" w="0">
+            <a:noFill/>
+          </a:ln>
+        </p:spPr>
+        <p:txBody>
+          <a:bodyPr xmlns:a="http://schemas.openxmlformats.org/drawingml/2006/main" anchor="ctr">
+            <a:normAutofit fontScale="100000"/>
+          </a:bodyPr>
+          <a:lstStyle xmlns:a="http://schemas.openxmlformats.org/drawingml/2006/main"/>
+          <a:p xmlns:a="http://schemas.openxmlformats.org/drawingml/2006/main">
+            <a:pPr algn="ctr">
+              <a:defRPr sz="1650" b="1">
+                <a:solidFill>
+                  <a:srgbClr val="F0F4F8"/>
+                </a:solidFill>
+                <a:latin typeface="Calibri"/>
+                <a:ea typeface="Calibri"/>
+                <a:cs typeface="Calibri"/>
+              </a:defRPr>
+            </a:pPr>
+            <a:r>
+              <a:rPr sz="1650" b="1">
+                <a:solidFill>
+                  <a:srgbClr val="F0F4F8"/>
+                </a:solidFill>
+                <a:latin typeface="Calibri"/>
+                <a:ea typeface="Calibri"/>
+                <a:cs typeface="Calibri"/>
+              </a:rPr>
+              <a:t>結果は仮説形成の手がかりとして読む</a:t>
+            </a:r>
+          </a:p>
+        </p:txBody>
+      </p:sp>
+    </p:spTree>
+    <p:extLst>
+      <p:ext uri="{BB962C8B-B14F-4D97-AF65-F5344CB8AC3E}">
+        <p14:creationId xmlns:p14="http://schemas.microsoft.com/office/powerpoint/2010/main" val="1740031507"/>
+      </p:ext>
+    </p:extLst>
+  </p:cSld>
 </p:sld>
 </file>
 

</xml_diff>